<commit_message>
some updates to the hadoop echo system
</commit_message>
<xml_diff>
--- a/20243/section_2_introduction_to_hadoop_eco_system/2-Introduction to Hadoop Eco System.pptx
+++ b/20243/section_2_introduction_to_hadoop_eco_system/2-Introduction to Hadoop Eco System.pptx
@@ -5,7 +5,7 @@
     <p:sldMasterId id="2147483648" r:id="rId1"/>
   </p:sldMasterIdLst>
   <p:notesMasterIdLst>
-    <p:notesMasterId r:id="rId41"/>
+    <p:notesMasterId r:id="rId40"/>
   </p:notesMasterIdLst>
   <p:sldIdLst>
     <p:sldId id="256" r:id="rId2"/>
@@ -44,9 +44,8 @@
     <p:sldId id="323" r:id="rId35"/>
     <p:sldId id="324" r:id="rId36"/>
     <p:sldId id="349" r:id="rId37"/>
-    <p:sldId id="350" r:id="rId38"/>
-    <p:sldId id="332" r:id="rId39"/>
-    <p:sldId id="333" r:id="rId40"/>
+    <p:sldId id="332" r:id="rId38"/>
+    <p:sldId id="333" r:id="rId39"/>
   </p:sldIdLst>
   <p:sldSz cx="12192000" cy="6858000"/>
   <p:notesSz cx="6858000" cy="9144000"/>
@@ -165,7 +164,7 @@
 <file path=ppt/revisionInfo.xml><?xml version="1.0" encoding="utf-8"?>
 <p1510:revInfo xmlns:a="http://schemas.openxmlformats.org/drawingml/2006/main" xmlns:r="http://schemas.openxmlformats.org/officeDocument/2006/relationships" xmlns:p1510="http://schemas.microsoft.com/office/powerpoint/2015/10/main">
   <p1510:revLst>
-    <p1510:client id="{2C5724D6-962A-4BB5-B62E-9C76E04FD5FB}" v="69" dt="2025-07-26T19:44:27.354"/>
+    <p1510:client id="{2C5724D6-962A-4BB5-B62E-9C76E04FD5FB}" v="84" dt="2025-07-26T20:08:35.219"/>
   </p1510:revLst>
 </p1510:revInfo>
 </file>
@@ -326,7 +325,7 @@
   <pc:docChgLst>
     <pc:chgData name="Mohammed Fasha" userId="cc64f42d-a1a6-4f08-b97b-0c37f877119f" providerId="ADAL" clId="{2C5724D6-962A-4BB5-B62E-9C76E04FD5FB}"/>
     <pc:docChg chg="undo custSel addSld delSld modSld sldOrd">
-      <pc:chgData name="Mohammed Fasha" userId="cc64f42d-a1a6-4f08-b97b-0c37f877119f" providerId="ADAL" clId="{2C5724D6-962A-4BB5-B62E-9C76E04FD5FB}" dt="2025-07-26T19:45:11.023" v="521" actId="2696"/>
+      <pc:chgData name="Mohammed Fasha" userId="cc64f42d-a1a6-4f08-b97b-0c37f877119f" providerId="ADAL" clId="{2C5724D6-962A-4BB5-B62E-9C76E04FD5FB}" dt="2025-07-26T20:08:42.842" v="561" actId="14734"/>
       <pc:docMkLst>
         <pc:docMk/>
       </pc:docMkLst>
@@ -713,6 +712,21 @@
           </ac:picMkLst>
         </pc:picChg>
       </pc:sldChg>
+      <pc:sldChg chg="modSp">
+        <pc:chgData name="Mohammed Fasha" userId="cc64f42d-a1a6-4f08-b97b-0c37f877119f" providerId="ADAL" clId="{2C5724D6-962A-4BB5-B62E-9C76E04FD5FB}" dt="2025-07-26T20:03:59.856" v="525" actId="1076"/>
+        <pc:sldMkLst>
+          <pc:docMk/>
+          <pc:sldMk cId="0" sldId="278"/>
+        </pc:sldMkLst>
+        <pc:picChg chg="mod">
+          <ac:chgData name="Mohammed Fasha" userId="cc64f42d-a1a6-4f08-b97b-0c37f877119f" providerId="ADAL" clId="{2C5724D6-962A-4BB5-B62E-9C76E04FD5FB}" dt="2025-07-26T20:03:59.856" v="525" actId="1076"/>
+          <ac:picMkLst>
+            <pc:docMk/>
+            <pc:sldMk cId="0" sldId="278"/>
+            <ac:picMk id="2050" creationId="{232D760D-CBEA-0B66-CBCC-A5D70A94C927}"/>
+          </ac:picMkLst>
+        </pc:picChg>
+      </pc:sldChg>
       <pc:sldChg chg="modSp mod chgLayout">
         <pc:chgData name="Mohammed Fasha" userId="cc64f42d-a1a6-4f08-b97b-0c37f877119f" providerId="ADAL" clId="{2C5724D6-962A-4BB5-B62E-9C76E04FD5FB}" dt="2025-07-26T18:21:46.792" v="106" actId="27636"/>
         <pc:sldMkLst>
@@ -904,6 +918,21 @@
           <pc:sldMk cId="1195465549" sldId="325"/>
         </pc:sldMkLst>
       </pc:sldChg>
+      <pc:sldChg chg="modSp">
+        <pc:chgData name="Mohammed Fasha" userId="cc64f42d-a1a6-4f08-b97b-0c37f877119f" providerId="ADAL" clId="{2C5724D6-962A-4BB5-B62E-9C76E04FD5FB}" dt="2025-07-26T20:03:52.352" v="523" actId="1076"/>
+        <pc:sldMkLst>
+          <pc:docMk/>
+          <pc:sldMk cId="932796301" sldId="328"/>
+        </pc:sldMkLst>
+        <pc:picChg chg="mod">
+          <ac:chgData name="Mohammed Fasha" userId="cc64f42d-a1a6-4f08-b97b-0c37f877119f" providerId="ADAL" clId="{2C5724D6-962A-4BB5-B62E-9C76E04FD5FB}" dt="2025-07-26T20:03:52.352" v="523" actId="1076"/>
+          <ac:picMkLst>
+            <pc:docMk/>
+            <pc:sldMk cId="932796301" sldId="328"/>
+            <ac:picMk id="4098" creationId="{0CAA22BE-1351-B1A5-188C-DD41EC29B52D}"/>
+          </ac:picMkLst>
+        </pc:picChg>
+      </pc:sldChg>
       <pc:sldChg chg="modSp mod">
         <pc:chgData name="Mohammed Fasha" userId="cc64f42d-a1a6-4f08-b97b-0c37f877119f" providerId="ADAL" clId="{2C5724D6-962A-4BB5-B62E-9C76E04FD5FB}" dt="2025-07-26T18:19:35.510" v="84" actId="790"/>
         <pc:sldMkLst>
@@ -996,13 +1025,13 @@
         </pc:spChg>
       </pc:sldChg>
       <pc:sldChg chg="addSp modSp mod">
-        <pc:chgData name="Mohammed Fasha" userId="cc64f42d-a1a6-4f08-b97b-0c37f877119f" providerId="ADAL" clId="{2C5724D6-962A-4BB5-B62E-9C76E04FD5FB}" dt="2025-07-26T18:28:08.155" v="139" actId="1076"/>
+        <pc:chgData name="Mohammed Fasha" userId="cc64f42d-a1a6-4f08-b97b-0c37f877119f" providerId="ADAL" clId="{2C5724D6-962A-4BB5-B62E-9C76E04FD5FB}" dt="2025-07-26T20:05:03.779" v="529" actId="790"/>
         <pc:sldMkLst>
           <pc:docMk/>
           <pc:sldMk cId="78335346" sldId="343"/>
         </pc:sldMkLst>
         <pc:spChg chg="add mod">
-          <ac:chgData name="Mohammed Fasha" userId="cc64f42d-a1a6-4f08-b97b-0c37f877119f" providerId="ADAL" clId="{2C5724D6-962A-4BB5-B62E-9C76E04FD5FB}" dt="2025-07-26T18:28:08.155" v="139" actId="1076"/>
+          <ac:chgData name="Mohammed Fasha" userId="cc64f42d-a1a6-4f08-b97b-0c37f877119f" providerId="ADAL" clId="{2C5724D6-962A-4BB5-B62E-9C76E04FD5FB}" dt="2025-07-26T20:05:03.779" v="529" actId="790"/>
           <ac:spMkLst>
             <pc:docMk/>
             <pc:sldMk cId="78335346" sldId="343"/>
@@ -1019,13 +1048,13 @@
         </pc:spChg>
       </pc:sldChg>
       <pc:sldChg chg="modSp mod">
-        <pc:chgData name="Mohammed Fasha" userId="cc64f42d-a1a6-4f08-b97b-0c37f877119f" providerId="ADAL" clId="{2C5724D6-962A-4BB5-B62E-9C76E04FD5FB}" dt="2025-07-26T19:12:27.791" v="142" actId="120"/>
+        <pc:chgData name="Mohammed Fasha" userId="cc64f42d-a1a6-4f08-b97b-0c37f877119f" providerId="ADAL" clId="{2C5724D6-962A-4BB5-B62E-9C76E04FD5FB}" dt="2025-07-26T20:04:40.233" v="528" actId="20577"/>
         <pc:sldMkLst>
           <pc:docMk/>
           <pc:sldMk cId="1605944735" sldId="345"/>
         </pc:sldMkLst>
         <pc:graphicFrameChg chg="modGraphic">
-          <ac:chgData name="Mohammed Fasha" userId="cc64f42d-a1a6-4f08-b97b-0c37f877119f" providerId="ADAL" clId="{2C5724D6-962A-4BB5-B62E-9C76E04FD5FB}" dt="2025-07-26T19:12:27.791" v="142" actId="120"/>
+          <ac:chgData name="Mohammed Fasha" userId="cc64f42d-a1a6-4f08-b97b-0c37f877119f" providerId="ADAL" clId="{2C5724D6-962A-4BB5-B62E-9C76E04FD5FB}" dt="2025-07-26T20:04:40.233" v="528" actId="20577"/>
           <ac:graphicFrameMkLst>
             <pc:docMk/>
             <pc:sldMk cId="1605944735" sldId="345"/>
@@ -1231,7 +1260,7 @@
         </pc:spChg>
       </pc:sldChg>
       <pc:sldChg chg="addSp delSp modSp new mod ord modClrScheme chgLayout">
-        <pc:chgData name="Mohammed Fasha" userId="cc64f42d-a1a6-4f08-b97b-0c37f877119f" providerId="ADAL" clId="{2C5724D6-962A-4BB5-B62E-9C76E04FD5FB}" dt="2025-07-26T19:44:24.496" v="518" actId="1076"/>
+        <pc:chgData name="Mohammed Fasha" userId="cc64f42d-a1a6-4f08-b97b-0c37f877119f" providerId="ADAL" clId="{2C5724D6-962A-4BB5-B62E-9C76E04FD5FB}" dt="2025-07-26T20:08:42.842" v="561" actId="14734"/>
         <pc:sldMkLst>
           <pc:docMk/>
           <pc:sldMk cId="1415635931" sldId="349"/>
@@ -1277,7 +1306,7 @@
           </ac:spMkLst>
         </pc:spChg>
         <pc:graphicFrameChg chg="add mod modGraphic">
-          <ac:chgData name="Mohammed Fasha" userId="cc64f42d-a1a6-4f08-b97b-0c37f877119f" providerId="ADAL" clId="{2C5724D6-962A-4BB5-B62E-9C76E04FD5FB}" dt="2025-07-26T19:41:10.417" v="480" actId="207"/>
+          <ac:chgData name="Mohammed Fasha" userId="cc64f42d-a1a6-4f08-b97b-0c37f877119f" providerId="ADAL" clId="{2C5724D6-962A-4BB5-B62E-9C76E04FD5FB}" dt="2025-07-26T20:08:42.842" v="561" actId="14734"/>
           <ac:graphicFrameMkLst>
             <pc:docMk/>
             <pc:sldMk cId="1415635931" sldId="349"/>
@@ -1293,8 +1322,8 @@
           </ac:graphicFrameMkLst>
         </pc:graphicFrameChg>
       </pc:sldChg>
-      <pc:sldChg chg="modSp add mod ord">
-        <pc:chgData name="Mohammed Fasha" userId="cc64f42d-a1a6-4f08-b97b-0c37f877119f" providerId="ADAL" clId="{2C5724D6-962A-4BB5-B62E-9C76E04FD5FB}" dt="2025-07-26T19:41:54.385" v="513"/>
+      <pc:sldChg chg="modSp add del mod ord">
+        <pc:chgData name="Mohammed Fasha" userId="cc64f42d-a1a6-4f08-b97b-0c37f877119f" providerId="ADAL" clId="{2C5724D6-962A-4BB5-B62E-9C76E04FD5FB}" dt="2025-07-26T20:06:51.577" v="551" actId="2696"/>
         <pc:sldMkLst>
           <pc:docMk/>
           <pc:sldMk cId="2432870720" sldId="350"/>
@@ -15153,8 +15182,8 @@
         </p:blipFill>
         <p:spPr bwMode="auto">
           <a:xfrm>
-            <a:off x="3164644" y="1607726"/>
-            <a:ext cx="562038" cy="562038"/>
+            <a:off x="3112764" y="1706007"/>
+            <a:ext cx="298895" cy="298895"/>
           </a:xfrm>
           <a:prstGeom prst="rect">
             <a:avLst/>
@@ -19962,8 +19991,8 @@
         </p:blipFill>
         <p:spPr bwMode="auto">
           <a:xfrm>
-            <a:off x="7392512" y="2293073"/>
-            <a:ext cx="421019" cy="421019"/>
+            <a:off x="7398998" y="2331984"/>
+            <a:ext cx="240458" cy="240458"/>
           </a:xfrm>
           <a:prstGeom prst="rect">
             <a:avLst/>
@@ -22328,7 +22357,7 @@
             <p:ph idx="1"/>
             <p:extLst>
               <p:ext uri="{D42A27DB-BD31-4B8C-83A1-F6EECF244321}">
-                <p14:modId xmlns:p14="http://schemas.microsoft.com/office/powerpoint/2010/main" val="3369760204"/>
+                <p14:modId xmlns:p14="http://schemas.microsoft.com/office/powerpoint/2010/main" val="3267030323"/>
               </p:ext>
             </p:extLst>
           </p:nvPr>
@@ -22386,7 +22415,7 @@
                     <a:bodyPr/>
                     <a:lstStyle/>
                     <a:p>
-                      <a:pPr algn="l" fontAlgn="ctr"/>
+                      <a:pPr algn="ctr" fontAlgn="ctr"/>
                       <a:r>
                         <a:rPr lang="en-US" sz="1400" u="none" strike="noStrike" dirty="0">
                           <a:effectLst/>
@@ -22402,14 +22431,20 @@
                       </a:endParaRPr>
                     </a:p>
                   </a:txBody>
-                  <a:tcPr marL="3781" marR="3781" marT="3781" marB="0" anchor="ctr"/>
+                  <a:tcPr marL="3781" marR="3781" marT="3781" marB="0" anchor="ctr">
+                    <a:solidFill>
+                      <a:schemeClr val="bg1">
+                        <a:lumMod val="85000"/>
+                      </a:schemeClr>
+                    </a:solidFill>
+                  </a:tcPr>
                 </a:tc>
                 <a:tc>
                   <a:txBody>
                     <a:bodyPr/>
                     <a:lstStyle/>
                     <a:p>
-                      <a:pPr algn="l" fontAlgn="ctr"/>
+                      <a:pPr algn="ctr" fontAlgn="ctr"/>
                       <a:r>
                         <a:rPr lang="en-US" sz="1400" u="none" strike="noStrike">
                           <a:effectLst/>
@@ -22425,14 +22460,20 @@
                       </a:endParaRPr>
                     </a:p>
                   </a:txBody>
-                  <a:tcPr marL="3781" marR="3781" marT="3781" marB="0" anchor="ctr"/>
+                  <a:tcPr marL="3781" marR="3781" marT="3781" marB="0" anchor="ctr">
+                    <a:solidFill>
+                      <a:schemeClr val="bg1">
+                        <a:lumMod val="85000"/>
+                      </a:schemeClr>
+                    </a:solidFill>
+                  </a:tcPr>
                 </a:tc>
                 <a:tc>
                   <a:txBody>
                     <a:bodyPr/>
                     <a:lstStyle/>
                     <a:p>
-                      <a:pPr algn="l" fontAlgn="ctr"/>
+                      <a:pPr algn="ctr" fontAlgn="ctr"/>
                       <a:r>
                         <a:rPr lang="en-US" sz="1400" u="none" strike="noStrike">
                           <a:effectLst/>
@@ -22448,21 +22489,36 @@
                       </a:endParaRPr>
                     </a:p>
                   </a:txBody>
-                  <a:tcPr marL="3781" marR="3781" marT="3781" marB="0" anchor="ctr"/>
+                  <a:tcPr marL="3781" marR="3781" marT="3781" marB="0" anchor="ctr">
+                    <a:solidFill>
+                      <a:schemeClr val="bg1">
+                        <a:lumMod val="85000"/>
+                      </a:schemeClr>
+                    </a:solidFill>
+                  </a:tcPr>
                 </a:tc>
                 <a:tc>
                   <a:txBody>
                     <a:bodyPr/>
                     <a:lstStyle/>
                     <a:p>
-                      <a:pPr algn="l" fontAlgn="ctr"/>
+                      <a:pPr algn="ctr" fontAlgn="ctr"/>
                       <a:r>
-                        <a:rPr lang="en-US" sz="1400" u="none" strike="noStrike">
+                        <a:rPr lang="en-US" sz="1400" u="none" strike="noStrike" dirty="0">
                           <a:effectLst/>
                         </a:rPr>
-                        <a:t>Consumer (Receives &amp; Processes Data)</a:t>
+                        <a:t>Consumer </a:t>
                       </a:r>
-                      <a:endParaRPr lang="en-US" sz="1400" b="1" i="0" u="none" strike="noStrike">
+                    </a:p>
+                    <a:p>
+                      <a:pPr algn="ctr" fontAlgn="ctr"/>
+                      <a:r>
+                        <a:rPr lang="en-US" sz="1400" u="none" strike="noStrike" dirty="0">
+                          <a:effectLst/>
+                        </a:rPr>
+                        <a:t>(Receives &amp; Processes Data)</a:t>
+                      </a:r>
+                      <a:endParaRPr lang="en-US" sz="1400" b="1" i="0" u="none" strike="noStrike" dirty="0">
                         <a:solidFill>
                           <a:srgbClr val="000000"/>
                         </a:solidFill>
@@ -22471,14 +22527,20 @@
                       </a:endParaRPr>
                     </a:p>
                   </a:txBody>
-                  <a:tcPr marL="3781" marR="3781" marT="3781" marB="0" anchor="ctr"/>
+                  <a:tcPr marL="3781" marR="3781" marT="3781" marB="0" anchor="ctr">
+                    <a:solidFill>
+                      <a:schemeClr val="bg1">
+                        <a:lumMod val="85000"/>
+                      </a:schemeClr>
+                    </a:solidFill>
+                  </a:tcPr>
                 </a:tc>
                 <a:tc>
                   <a:txBody>
                     <a:bodyPr/>
                     <a:lstStyle/>
                     <a:p>
-                      <a:pPr algn="l" fontAlgn="ctr"/>
+                      <a:pPr algn="ctr" fontAlgn="ctr"/>
                       <a:r>
                         <a:rPr lang="en-US" sz="1400" u="none" strike="noStrike" dirty="0">
                           <a:effectLst/>
@@ -22494,7 +22556,13 @@
                       </a:endParaRPr>
                     </a:p>
                   </a:txBody>
-                  <a:tcPr marL="3781" marR="3781" marT="3781" marB="0" anchor="ctr"/>
+                  <a:tcPr marL="3781" marR="3781" marT="3781" marB="0" anchor="ctr">
+                    <a:solidFill>
+                      <a:schemeClr val="bg1">
+                        <a:lumMod val="85000"/>
+                      </a:schemeClr>
+                    </a:solidFill>
+                  </a:tcPr>
                 </a:tc>
                 <a:extLst>
                   <a:ext uri="{0D108BD9-81ED-4DB2-BD59-A6C34878D82A}">
@@ -23795,7 +23863,7 @@
               <a:buNone/>
             </a:pPr>
             <a:r>
-              <a:rPr lang="en-US" sz="1800" dirty="0">
+              <a:rPr lang="en-US" sz="1800" noProof="1">
                 <a:solidFill>
                   <a:srgbClr val="00B050"/>
                 </a:solidFill>
@@ -23804,7 +23872,7 @@
               </a:rPr>
               <a:t>Order Message (from storefront):</a:t>
             </a:r>
-            <a:endParaRPr lang="en-US" sz="1800" dirty="0">
+            <a:endParaRPr lang="en-US" sz="1800" noProof="1">
               <a:solidFill>
                 <a:srgbClr val="00B050"/>
               </a:solidFill>
@@ -23842,7 +23910,7 @@
               </a:tabLst>
             </a:pPr>
             <a:r>
-              <a:rPr lang="en-US" sz="1800" dirty="0">
+              <a:rPr lang="en-US" sz="1800" noProof="1">
                 <a:solidFill>
                   <a:srgbClr val="00B050"/>
                 </a:solidFill>
@@ -23852,7 +23920,7 @@
               </a:rPr>
               <a:t>{</a:t>
             </a:r>
-            <a:endParaRPr lang="en-US" sz="1800" dirty="0">
+            <a:endParaRPr lang="en-US" sz="1800" noProof="1">
               <a:solidFill>
                 <a:srgbClr val="00B050"/>
               </a:solidFill>
@@ -23891,7 +23959,7 @@
               </a:tabLst>
             </a:pPr>
             <a:r>
-              <a:rPr lang="en-US" sz="1800" dirty="0">
+              <a:rPr lang="en-US" sz="1800" noProof="1">
                 <a:solidFill>
                   <a:srgbClr val="00B050"/>
                 </a:solidFill>
@@ -23899,31 +23967,9 @@
                 <a:ea typeface="Times New Roman" panose="02020603050405020304" pitchFamily="18" charset="0"/>
                 <a:cs typeface="Arial" panose="020B0604020202020204" pitchFamily="34" charset="0"/>
               </a:rPr>
-              <a:t>  "</a:t>
-            </a:r>
-            <a:r>
-              <a:rPr lang="en-US" sz="1800" dirty="0" err="1">
-                <a:solidFill>
-                  <a:srgbClr val="00B050"/>
-                </a:solidFill>
-                <a:latin typeface="Courier New" panose="02070309020205020404" pitchFamily="49" charset="0"/>
-                <a:ea typeface="Times New Roman" panose="02020603050405020304" pitchFamily="18" charset="0"/>
-                <a:cs typeface="Arial" panose="020B0604020202020204" pitchFamily="34" charset="0"/>
-              </a:rPr>
-              <a:t>order_id</a:t>
-            </a:r>
-            <a:r>
-              <a:rPr lang="en-US" sz="1800" dirty="0">
-                <a:solidFill>
-                  <a:srgbClr val="00B050"/>
-                </a:solidFill>
-                <a:latin typeface="Courier New" panose="02070309020205020404" pitchFamily="49" charset="0"/>
-                <a:ea typeface="Times New Roman" panose="02020603050405020304" pitchFamily="18" charset="0"/>
-                <a:cs typeface="Arial" panose="020B0604020202020204" pitchFamily="34" charset="0"/>
-              </a:rPr>
-              <a:t>": "ord12345",</a:t>
-            </a:r>
-            <a:endParaRPr lang="en-US" sz="1800" dirty="0">
+              <a:t>  "order_id": "ord12345",</a:t>
+            </a:r>
+            <a:endParaRPr lang="en-US" sz="1800" noProof="1">
               <a:solidFill>
                 <a:srgbClr val="00B050"/>
               </a:solidFill>
@@ -23962,7 +24008,7 @@
               </a:tabLst>
             </a:pPr>
             <a:r>
-              <a:rPr lang="en-US" sz="1800" dirty="0">
+              <a:rPr lang="en-US" sz="1800" noProof="1">
                 <a:solidFill>
                   <a:srgbClr val="00B050"/>
                 </a:solidFill>
@@ -23972,7 +24018,7 @@
               </a:rPr>
               <a:t>  "timestamp": "2025-03-25T10:10:30Z",</a:t>
             </a:r>
-            <a:endParaRPr lang="en-US" sz="1800" dirty="0">
+            <a:endParaRPr lang="en-US" sz="1800" noProof="1">
               <a:solidFill>
                 <a:srgbClr val="00B050"/>
               </a:solidFill>
@@ -24011,7 +24057,7 @@
               </a:tabLst>
             </a:pPr>
             <a:r>
-              <a:rPr lang="en-US" sz="1800" dirty="0">
+              <a:rPr lang="en-US" sz="1800" noProof="1">
                 <a:solidFill>
                   <a:srgbClr val="00B050"/>
                 </a:solidFill>
@@ -24019,31 +24065,9 @@
                 <a:ea typeface="Times New Roman" panose="02020603050405020304" pitchFamily="18" charset="0"/>
                 <a:cs typeface="Arial" panose="020B0604020202020204" pitchFamily="34" charset="0"/>
               </a:rPr>
-              <a:t>  "</a:t>
-            </a:r>
-            <a:r>
-              <a:rPr lang="en-US" sz="1800" dirty="0" err="1">
-                <a:solidFill>
-                  <a:srgbClr val="00B050"/>
-                </a:solidFill>
-                <a:latin typeface="Courier New" panose="02070309020205020404" pitchFamily="49" charset="0"/>
-                <a:ea typeface="Times New Roman" panose="02020603050405020304" pitchFamily="18" charset="0"/>
-                <a:cs typeface="Arial" panose="020B0604020202020204" pitchFamily="34" charset="0"/>
-              </a:rPr>
-              <a:t>customer_id</a:t>
-            </a:r>
-            <a:r>
-              <a:rPr lang="en-US" sz="1800" dirty="0">
-                <a:solidFill>
-                  <a:srgbClr val="00B050"/>
-                </a:solidFill>
-                <a:latin typeface="Courier New" panose="02070309020205020404" pitchFamily="49" charset="0"/>
-                <a:ea typeface="Times New Roman" panose="02020603050405020304" pitchFamily="18" charset="0"/>
-                <a:cs typeface="Arial" panose="020B0604020202020204" pitchFamily="34" charset="0"/>
-              </a:rPr>
-              <a:t>": "cust456",</a:t>
-            </a:r>
-            <a:endParaRPr lang="en-US" sz="1800" dirty="0">
+              <a:t>  "customer_id": "cust456",</a:t>
+            </a:r>
+            <a:endParaRPr lang="en-US" sz="1800" noProof="1">
               <a:solidFill>
                 <a:srgbClr val="00B050"/>
               </a:solidFill>
@@ -24082,7 +24106,7 @@
               </a:tabLst>
             </a:pPr>
             <a:r>
-              <a:rPr lang="en-US" sz="1800" dirty="0">
+              <a:rPr lang="en-US" sz="1800" noProof="1">
                 <a:solidFill>
                   <a:srgbClr val="00B050"/>
                 </a:solidFill>
@@ -24092,7 +24116,7 @@
               </a:rPr>
               <a:t>  "items": [</a:t>
             </a:r>
-            <a:endParaRPr lang="en-US" sz="1800" dirty="0">
+            <a:endParaRPr lang="en-US" sz="1800" noProof="1">
               <a:solidFill>
                 <a:srgbClr val="00B050"/>
               </a:solidFill>
@@ -24131,7 +24155,7 @@
               </a:tabLst>
             </a:pPr>
             <a:r>
-              <a:rPr lang="en-US" sz="1800" dirty="0">
+              <a:rPr lang="en-US" sz="1800" noProof="1">
                 <a:solidFill>
                   <a:srgbClr val="00B050"/>
                 </a:solidFill>
@@ -24139,31 +24163,9 @@
                 <a:ea typeface="Times New Roman" panose="02020603050405020304" pitchFamily="18" charset="0"/>
                 <a:cs typeface="Arial" panose="020B0604020202020204" pitchFamily="34" charset="0"/>
               </a:rPr>
-              <a:t>    {"</a:t>
-            </a:r>
-            <a:r>
-              <a:rPr lang="en-US" sz="1800" dirty="0" err="1">
-                <a:solidFill>
-                  <a:srgbClr val="00B050"/>
-                </a:solidFill>
-                <a:latin typeface="Courier New" panose="02070309020205020404" pitchFamily="49" charset="0"/>
-                <a:ea typeface="Times New Roman" panose="02020603050405020304" pitchFamily="18" charset="0"/>
-                <a:cs typeface="Arial" panose="020B0604020202020204" pitchFamily="34" charset="0"/>
-              </a:rPr>
-              <a:t>product_id</a:t>
-            </a:r>
-            <a:r>
-              <a:rPr lang="en-US" sz="1800" dirty="0">
-                <a:solidFill>
-                  <a:srgbClr val="00B050"/>
-                </a:solidFill>
-                <a:latin typeface="Courier New" panose="02070309020205020404" pitchFamily="49" charset="0"/>
-                <a:ea typeface="Times New Roman" panose="02020603050405020304" pitchFamily="18" charset="0"/>
-                <a:cs typeface="Arial" panose="020B0604020202020204" pitchFamily="34" charset="0"/>
-              </a:rPr>
-              <a:t>": "prod678", "quantity": 2},</a:t>
-            </a:r>
-            <a:endParaRPr lang="en-US" sz="1800" dirty="0">
+              <a:t>    {"product_id": "prod678", "quantity": 2},</a:t>
+            </a:r>
+            <a:endParaRPr lang="en-US" sz="1800" noProof="1">
               <a:solidFill>
                 <a:srgbClr val="00B050"/>
               </a:solidFill>
@@ -24202,7 +24204,7 @@
               </a:tabLst>
             </a:pPr>
             <a:r>
-              <a:rPr lang="en-US" sz="1800" dirty="0">
+              <a:rPr lang="en-US" sz="1800" noProof="1">
                 <a:solidFill>
                   <a:srgbClr val="00B050"/>
                 </a:solidFill>
@@ -24210,31 +24212,9 @@
                 <a:ea typeface="Times New Roman" panose="02020603050405020304" pitchFamily="18" charset="0"/>
                 <a:cs typeface="Arial" panose="020B0604020202020204" pitchFamily="34" charset="0"/>
               </a:rPr>
-              <a:t>    {"</a:t>
-            </a:r>
-            <a:r>
-              <a:rPr lang="en-US" sz="1800" dirty="0" err="1">
-                <a:solidFill>
-                  <a:srgbClr val="00B050"/>
-                </a:solidFill>
-                <a:latin typeface="Courier New" panose="02070309020205020404" pitchFamily="49" charset="0"/>
-                <a:ea typeface="Times New Roman" panose="02020603050405020304" pitchFamily="18" charset="0"/>
-                <a:cs typeface="Arial" panose="020B0604020202020204" pitchFamily="34" charset="0"/>
-              </a:rPr>
-              <a:t>product_id</a:t>
-            </a:r>
-            <a:r>
-              <a:rPr lang="en-US" sz="1800" dirty="0">
-                <a:solidFill>
-                  <a:srgbClr val="00B050"/>
-                </a:solidFill>
-                <a:latin typeface="Courier New" panose="02070309020205020404" pitchFamily="49" charset="0"/>
-                <a:ea typeface="Times New Roman" panose="02020603050405020304" pitchFamily="18" charset="0"/>
-                <a:cs typeface="Arial" panose="020B0604020202020204" pitchFamily="34" charset="0"/>
-              </a:rPr>
-              <a:t>": "prod789", "quantity": 1}</a:t>
-            </a:r>
-            <a:endParaRPr lang="en-US" sz="1800" dirty="0">
+              <a:t>    {"product_id": "prod789", "quantity": 1}</a:t>
+            </a:r>
+            <a:endParaRPr lang="en-US" sz="1800" noProof="1">
               <a:solidFill>
                 <a:srgbClr val="00B050"/>
               </a:solidFill>
@@ -24273,7 +24253,7 @@
               </a:tabLst>
             </a:pPr>
             <a:r>
-              <a:rPr lang="en-US" sz="1800" dirty="0">
+              <a:rPr lang="en-US" sz="1800" noProof="1">
                 <a:solidFill>
                   <a:srgbClr val="00B050"/>
                 </a:solidFill>
@@ -24283,7 +24263,7 @@
               </a:rPr>
               <a:t>  ],</a:t>
             </a:r>
-            <a:endParaRPr lang="en-US" sz="1800" dirty="0">
+            <a:endParaRPr lang="en-US" sz="1800" noProof="1">
               <a:solidFill>
                 <a:srgbClr val="00B050"/>
               </a:solidFill>
@@ -24322,7 +24302,7 @@
               </a:tabLst>
             </a:pPr>
             <a:r>
-              <a:rPr lang="en-US" sz="1800" dirty="0">
+              <a:rPr lang="en-US" sz="1800" noProof="1">
                 <a:solidFill>
                   <a:srgbClr val="00B050"/>
                 </a:solidFill>
@@ -24330,31 +24310,9 @@
                 <a:ea typeface="Times New Roman" panose="02020603050405020304" pitchFamily="18" charset="0"/>
                 <a:cs typeface="Arial" panose="020B0604020202020204" pitchFamily="34" charset="0"/>
               </a:rPr>
-              <a:t>  "</a:t>
-            </a:r>
-            <a:r>
-              <a:rPr lang="en-US" sz="1800" dirty="0" err="1">
-                <a:solidFill>
-                  <a:srgbClr val="00B050"/>
-                </a:solidFill>
-                <a:latin typeface="Courier New" panose="02070309020205020404" pitchFamily="49" charset="0"/>
-                <a:ea typeface="Times New Roman" panose="02020603050405020304" pitchFamily="18" charset="0"/>
-                <a:cs typeface="Arial" panose="020B0604020202020204" pitchFamily="34" charset="0"/>
-              </a:rPr>
-              <a:t>total_amount</a:t>
-            </a:r>
-            <a:r>
-              <a:rPr lang="en-US" sz="1800" dirty="0">
-                <a:solidFill>
-                  <a:srgbClr val="00B050"/>
-                </a:solidFill>
-                <a:latin typeface="Courier New" panose="02070309020205020404" pitchFamily="49" charset="0"/>
-                <a:ea typeface="Times New Roman" panose="02020603050405020304" pitchFamily="18" charset="0"/>
-                <a:cs typeface="Arial" panose="020B0604020202020204" pitchFamily="34" charset="0"/>
-              </a:rPr>
-              <a:t>": 129.99,</a:t>
-            </a:r>
-            <a:endParaRPr lang="en-US" sz="1800" dirty="0">
+              <a:t>  "total_amount": 129.99,</a:t>
+            </a:r>
+            <a:endParaRPr lang="en-US" sz="1800" noProof="1">
               <a:solidFill>
                 <a:srgbClr val="00B050"/>
               </a:solidFill>
@@ -24393,7 +24351,7 @@
               </a:tabLst>
             </a:pPr>
             <a:r>
-              <a:rPr lang="en-US" sz="1800" dirty="0">
+              <a:rPr lang="en-US" sz="1800" noProof="1">
                 <a:solidFill>
                   <a:srgbClr val="00B050"/>
                 </a:solidFill>
@@ -24401,31 +24359,9 @@
                 <a:ea typeface="Times New Roman" panose="02020603050405020304" pitchFamily="18" charset="0"/>
                 <a:cs typeface="Arial" panose="020B0604020202020204" pitchFamily="34" charset="0"/>
               </a:rPr>
-              <a:t>  "</a:t>
-            </a:r>
-            <a:r>
-              <a:rPr lang="en-US" sz="1800" dirty="0" err="1">
-                <a:solidFill>
-                  <a:srgbClr val="00B050"/>
-                </a:solidFill>
-                <a:latin typeface="Courier New" panose="02070309020205020404" pitchFamily="49" charset="0"/>
-                <a:ea typeface="Times New Roman" panose="02020603050405020304" pitchFamily="18" charset="0"/>
-                <a:cs typeface="Arial" panose="020B0604020202020204" pitchFamily="34" charset="0"/>
-              </a:rPr>
-              <a:t>payment_status</a:t>
-            </a:r>
-            <a:r>
-              <a:rPr lang="en-US" sz="1800" dirty="0">
-                <a:solidFill>
-                  <a:srgbClr val="00B050"/>
-                </a:solidFill>
-                <a:latin typeface="Courier New" panose="02070309020205020404" pitchFamily="49" charset="0"/>
-                <a:ea typeface="Times New Roman" panose="02020603050405020304" pitchFamily="18" charset="0"/>
-                <a:cs typeface="Arial" panose="020B0604020202020204" pitchFamily="34" charset="0"/>
-              </a:rPr>
-              <a:t>": "paid",</a:t>
-            </a:r>
-            <a:endParaRPr lang="en-US" sz="1800" dirty="0">
+              <a:t>  "payment_status": "paid",</a:t>
+            </a:r>
+            <a:endParaRPr lang="en-US" sz="1800" noProof="1">
               <a:solidFill>
                 <a:srgbClr val="00B050"/>
               </a:solidFill>
@@ -24464,7 +24400,7 @@
               </a:tabLst>
             </a:pPr>
             <a:r>
-              <a:rPr lang="en-US" sz="1800" dirty="0">
+              <a:rPr lang="en-US" sz="1800" noProof="1">
                 <a:solidFill>
                   <a:srgbClr val="00B050"/>
                 </a:solidFill>
@@ -24472,31 +24408,9 @@
                 <a:ea typeface="Times New Roman" panose="02020603050405020304" pitchFamily="18" charset="0"/>
                 <a:cs typeface="Arial" panose="020B0604020202020204" pitchFamily="34" charset="0"/>
               </a:rPr>
-              <a:t>  "</a:t>
-            </a:r>
-            <a:r>
-              <a:rPr lang="en-US" sz="1800" dirty="0" err="1">
-                <a:solidFill>
-                  <a:srgbClr val="00B050"/>
-                </a:solidFill>
-                <a:latin typeface="Courier New" panose="02070309020205020404" pitchFamily="49" charset="0"/>
-                <a:ea typeface="Times New Roman" panose="02020603050405020304" pitchFamily="18" charset="0"/>
-                <a:cs typeface="Arial" panose="020B0604020202020204" pitchFamily="34" charset="0"/>
-              </a:rPr>
-              <a:t>shipping_address</a:t>
-            </a:r>
-            <a:r>
-              <a:rPr lang="en-US" sz="1800" dirty="0">
-                <a:solidFill>
-                  <a:srgbClr val="00B050"/>
-                </a:solidFill>
-                <a:latin typeface="Courier New" panose="02070309020205020404" pitchFamily="49" charset="0"/>
-                <a:ea typeface="Times New Roman" panose="02020603050405020304" pitchFamily="18" charset="0"/>
-                <a:cs typeface="Arial" panose="020B0604020202020204" pitchFamily="34" charset="0"/>
-              </a:rPr>
-              <a:t>": "123 Main St, Anytown, USA"</a:t>
-            </a:r>
-            <a:endParaRPr lang="en-US" sz="1800" dirty="0">
+              <a:t>  "shipping_address": "123 Main St, Anytown, USA"</a:t>
+            </a:r>
+            <a:endParaRPr lang="en-US" sz="1800" noProof="1">
               <a:solidFill>
                 <a:srgbClr val="00B050"/>
               </a:solidFill>
@@ -24535,7 +24449,7 @@
               </a:tabLst>
             </a:pPr>
             <a:r>
-              <a:rPr lang="en-US" sz="1800" dirty="0">
+              <a:rPr lang="en-US" sz="1800" noProof="1">
                 <a:solidFill>
                   <a:srgbClr val="00B050"/>
                 </a:solidFill>
@@ -24545,7 +24459,7 @@
               </a:rPr>
               <a:t>}</a:t>
             </a:r>
-            <a:endParaRPr lang="en-US" sz="1800" dirty="0">
+            <a:endParaRPr lang="en-US" sz="1800" noProof="1">
               <a:solidFill>
                 <a:srgbClr val="00B050"/>
               </a:solidFill>
@@ -24559,7 +24473,7 @@
               <a:buFont typeface="Arial" panose="020B0604020202020204" pitchFamily="34" charset="0"/>
               <a:buNone/>
             </a:pPr>
-            <a:endParaRPr lang="en-US" dirty="0">
+            <a:endParaRPr lang="en-US" noProof="1">
               <a:solidFill>
                 <a:srgbClr val="00B050"/>
               </a:solidFill>
@@ -33996,14 +33910,14 @@
             <p:ph idx="1"/>
             <p:extLst>
               <p:ext uri="{D42A27DB-BD31-4B8C-83A1-F6EECF244321}">
-                <p14:modId xmlns:p14="http://schemas.microsoft.com/office/powerpoint/2010/main" val="3750328245"/>
+                <p14:modId xmlns:p14="http://schemas.microsoft.com/office/powerpoint/2010/main" val="2322429672"/>
               </p:ext>
             </p:extLst>
           </p:nvPr>
         </p:nvGraphicFramePr>
         <p:xfrm>
           <a:off x="284085" y="1706564"/>
-          <a:ext cx="11051881" cy="3161268"/>
+          <a:ext cx="11051880" cy="4572000"/>
         </p:xfrm>
         <a:graphic>
           <a:graphicData uri="http://schemas.openxmlformats.org/drawingml/2006/table">
@@ -34012,21 +33926,21 @@
                 <a:tableStyleId>{616DA210-FB5B-4158-B5E0-FEB733F419BA}</a:tableStyleId>
               </a:tblPr>
               <a:tblGrid>
-                <a:gridCol w="1953277">
+                <a:gridCol w="2452630">
                   <a:extLst>
                     <a:ext uri="{9D8B030D-6E8A-4147-A177-3AD203B41FA5}">
                       <a16:colId xmlns:a16="http://schemas.microsoft.com/office/drawing/2014/main" val="4253224905"/>
                     </a:ext>
                   </a:extLst>
                 </a:gridCol>
-                <a:gridCol w="3581581">
+                <a:gridCol w="2172511">
                   <a:extLst>
                     <a:ext uri="{9D8B030D-6E8A-4147-A177-3AD203B41FA5}">
                       <a16:colId xmlns:a16="http://schemas.microsoft.com/office/drawing/2014/main" val="2322419839"/>
                     </a:ext>
                   </a:extLst>
                 </a:gridCol>
-                <a:gridCol w="5517023">
+                <a:gridCol w="6426739">
                   <a:extLst>
                     <a:ext uri="{9D8B030D-6E8A-4147-A177-3AD203B41FA5}">
                       <a16:colId xmlns:a16="http://schemas.microsoft.com/office/drawing/2014/main" val="3164467908"/>
@@ -34034,7 +33948,7 @@
                   </a:extLst>
                 </a:gridCol>
               </a:tblGrid>
-              <a:tr h="104526">
+              <a:tr h="228600">
                 <a:tc>
                   <a:txBody>
                     <a:bodyPr/>
@@ -34042,10 +33956,10 @@
                     <a:p>
                       <a:pPr algn="ctr"/>
                       <a:r>
-                        <a:rPr lang="en-US" sz="1600" b="1"/>
+                        <a:rPr lang="en-US" sz="1100" b="1"/>
                         <a:t>Category</a:t>
                       </a:r>
-                      <a:endParaRPr lang="en-US" sz="1600"/>
+                      <a:endParaRPr lang="en-US" sz="1100"/>
                     </a:p>
                   </a:txBody>
                   <a:tcPr marL="26131" marR="26131" marT="13066" marB="13066" anchor="ctr">
@@ -34063,10 +33977,10 @@
                     <a:p>
                       <a:pPr algn="ctr"/>
                       <a:r>
-                        <a:rPr lang="en-US" sz="1600" b="1"/>
+                        <a:rPr lang="en-US" sz="1100" b="1"/>
                         <a:t>Application</a:t>
                       </a:r>
-                      <a:endParaRPr lang="en-US" sz="1600"/>
+                      <a:endParaRPr lang="en-US" sz="1100"/>
                     </a:p>
                   </a:txBody>
                   <a:tcPr marL="26131" marR="26131" marT="13066" marB="13066" anchor="ctr">
@@ -34084,10 +33998,10 @@
                     <a:p>
                       <a:pPr algn="ctr"/>
                       <a:r>
-                        <a:rPr lang="en-US" sz="1600" b="1" dirty="0"/>
+                        <a:rPr lang="en-US" sz="1100" b="1" dirty="0"/>
                         <a:t>Description</a:t>
                       </a:r>
-                      <a:endParaRPr lang="en-US" sz="1600" dirty="0"/>
+                      <a:endParaRPr lang="en-US" sz="1100" dirty="0"/>
                     </a:p>
                   </a:txBody>
                   <a:tcPr marL="26131" marR="26131" marT="13066" marB="13066" anchor="ctr">
@@ -34104,17 +34018,17 @@
                   </a:ext>
                 </a:extLst>
               </a:tr>
-              <a:tr h="339708">
+              <a:tr h="228600">
                 <a:tc>
                   <a:txBody>
                     <a:bodyPr/>
                     <a:lstStyle/>
                     <a:p>
                       <a:r>
-                        <a:rPr lang="en-US" sz="1600" b="1"/>
+                        <a:rPr lang="en-US" sz="1100" b="1"/>
                         <a:t>Big Data Engines</a:t>
                       </a:r>
-                      <a:endParaRPr lang="en-US" sz="1600"/>
+                      <a:endParaRPr lang="en-US" sz="1100"/>
                     </a:p>
                   </a:txBody>
                   <a:tcPr marL="26131" marR="26131" marT="13066" marB="13066" anchor="ctr"/>
@@ -34125,7 +34039,7 @@
                     <a:lstStyle/>
                     <a:p>
                       <a:r>
-                        <a:rPr lang="en-US" sz="1600" dirty="0"/>
+                        <a:rPr lang="en-US" sz="1100" dirty="0"/>
                         <a:t>Apache Spark</a:t>
                       </a:r>
                     </a:p>
@@ -34138,7 +34052,7 @@
                     <a:lstStyle/>
                     <a:p>
                       <a:r>
-                        <a:rPr lang="en-US" sz="1600"/>
+                        <a:rPr lang="en-US" sz="1100"/>
                         <a:t>Fast in-memory distributed data processing for large-scale workloads.</a:t>
                       </a:r>
                     </a:p>
@@ -34151,13 +34065,13 @@
                   </a:ext>
                 </a:extLst>
               </a:tr>
-              <a:tr h="339708">
+              <a:tr h="228600">
                 <a:tc>
                   <a:txBody>
                     <a:bodyPr/>
                     <a:lstStyle/>
                     <a:p>
-                      <a:endParaRPr lang="en-US" sz="1600"/>
+                      <a:endParaRPr lang="en-US" sz="1100"/>
                     </a:p>
                   </a:txBody>
                   <a:tcPr marL="26131" marR="26131" marT="13066" marB="13066" anchor="ctr"/>
@@ -34168,7 +34082,7 @@
                     <a:lstStyle/>
                     <a:p>
                       <a:r>
-                        <a:rPr lang="en-US" sz="1600"/>
+                        <a:rPr lang="en-US" sz="1100"/>
                         <a:t>Hadoop</a:t>
                       </a:r>
                     </a:p>
@@ -34181,7 +34095,7 @@
                     <a:lstStyle/>
                     <a:p>
                       <a:r>
-                        <a:rPr lang="en-US" sz="1600"/>
+                        <a:rPr lang="en-US" sz="1100"/>
                         <a:t>Core framework for distributed storage (HDFS) and processing (MapReduce/YARN).</a:t>
                       </a:r>
                     </a:p>
@@ -34194,13 +34108,13 @@
                   </a:ext>
                 </a:extLst>
               </a:tr>
-              <a:tr h="339708">
+              <a:tr h="228600">
                 <a:tc>
                   <a:txBody>
                     <a:bodyPr/>
                     <a:lstStyle/>
                     <a:p>
-                      <a:endParaRPr lang="en-US" sz="1600" dirty="0"/>
+                      <a:endParaRPr lang="en-US" sz="1100" dirty="0"/>
                     </a:p>
                   </a:txBody>
                   <a:tcPr marL="26131" marR="26131" marT="13066" marB="13066" anchor="ctr"/>
@@ -34211,7 +34125,7 @@
                     <a:lstStyle/>
                     <a:p>
                       <a:r>
-                        <a:rPr lang="en-US" sz="1600"/>
+                        <a:rPr lang="en-US" sz="1100"/>
                         <a:t>Flink</a:t>
                       </a:r>
                     </a:p>
@@ -34224,7 +34138,7 @@
                     <a:lstStyle/>
                     <a:p>
                       <a:r>
-                        <a:rPr lang="en-US" sz="1600"/>
+                        <a:rPr lang="en-US" sz="1100"/>
                         <a:t>Real-time stream processing framework with high throughput and low latency.</a:t>
                       </a:r>
                     </a:p>
@@ -34237,13 +34151,13 @@
                   </a:ext>
                 </a:extLst>
               </a:tr>
-              <a:tr h="261314">
+              <a:tr h="228600">
                 <a:tc>
                   <a:txBody>
                     <a:bodyPr/>
                     <a:lstStyle/>
                     <a:p>
-                      <a:endParaRPr lang="en-US" sz="1600"/>
+                      <a:endParaRPr lang="en-US" sz="1100"/>
                     </a:p>
                   </a:txBody>
                   <a:tcPr marL="26131" marR="26131" marT="13066" marB="13066" anchor="ctr"/>
@@ -34254,7 +34168,7 @@
                     <a:lstStyle/>
                     <a:p>
                       <a:r>
-                        <a:rPr lang="en-US" sz="1600"/>
+                        <a:rPr lang="en-US" sz="1100"/>
                         <a:t>HBase</a:t>
                       </a:r>
                     </a:p>
@@ -34267,7 +34181,7 @@
                     <a:lstStyle/>
                     <a:p>
                       <a:r>
-                        <a:rPr lang="en-US" sz="1600"/>
+                        <a:rPr lang="en-US" sz="1100"/>
                         <a:t>NoSQL database for real-time read/write access on HDFS.</a:t>
                       </a:r>
                     </a:p>
@@ -34280,13 +34194,13 @@
                   </a:ext>
                 </a:extLst>
               </a:tr>
-              <a:tr h="261314">
+              <a:tr h="228600">
                 <a:tc>
                   <a:txBody>
                     <a:bodyPr/>
                     <a:lstStyle/>
                     <a:p>
-                      <a:endParaRPr lang="en-US" sz="1600"/>
+                      <a:endParaRPr lang="en-US" sz="1100"/>
                     </a:p>
                   </a:txBody>
                   <a:tcPr marL="26131" marR="26131" marT="13066" marB="13066" anchor="ctr"/>
@@ -34297,7 +34211,7 @@
                     <a:lstStyle/>
                     <a:p>
                       <a:r>
-                        <a:rPr lang="en-US" sz="1600"/>
+                        <a:rPr lang="en-US" sz="1100"/>
                         <a:t>Presto</a:t>
                       </a:r>
                     </a:p>
@@ -34310,7 +34224,7 @@
                     <a:lstStyle/>
                     <a:p>
                       <a:r>
-                        <a:rPr lang="en-US" sz="1600"/>
+                        <a:rPr lang="en-US" sz="1100"/>
                         <a:t>Distributed SQL query engine for large-scale interactive queries.</a:t>
                       </a:r>
                     </a:p>
@@ -34323,13 +34237,13 @@
                   </a:ext>
                 </a:extLst>
               </a:tr>
-              <a:tr h="261314">
+              <a:tr h="228600">
                 <a:tc>
                   <a:txBody>
                     <a:bodyPr/>
                     <a:lstStyle/>
                     <a:p>
-                      <a:endParaRPr lang="en-US" sz="1600"/>
+                      <a:endParaRPr lang="en-US" sz="1100"/>
                     </a:p>
                   </a:txBody>
                   <a:tcPr marL="26131" marR="26131" marT="13066" marB="13066" anchor="ctr"/>
@@ -34340,7 +34254,7 @@
                     <a:lstStyle/>
                     <a:p>
                       <a:r>
-                        <a:rPr lang="en-US" sz="1600"/>
+                        <a:rPr lang="en-US" sz="1100"/>
                         <a:t>Trino</a:t>
                       </a:r>
                     </a:p>
@@ -34353,7 +34267,7 @@
                     <a:lstStyle/>
                     <a:p>
                       <a:r>
-                        <a:rPr lang="en-US" sz="1600"/>
+                        <a:rPr lang="en-US" sz="1100"/>
                         <a:t>High-performance distributed SQL engine (PrestoSQL fork).</a:t>
                       </a:r>
                     </a:p>
@@ -34366,17 +34280,17 @@
                   </a:ext>
                 </a:extLst>
               </a:tr>
-              <a:tr h="261314">
+              <a:tr h="228600">
                 <a:tc>
                   <a:txBody>
                     <a:bodyPr/>
                     <a:lstStyle/>
                     <a:p>
                       <a:r>
-                        <a:rPr lang="en-US" sz="1600" b="1"/>
+                        <a:rPr lang="en-US" sz="1100" b="1"/>
                         <a:t>Notebook Interfaces</a:t>
                       </a:r>
-                      <a:endParaRPr lang="en-US" sz="1600"/>
+                      <a:endParaRPr lang="en-US" sz="1100"/>
                     </a:p>
                   </a:txBody>
                   <a:tcPr marL="26131" marR="26131" marT="13066" marB="13066" anchor="ctr"/>
@@ -34387,9 +34301,10 @@
                     <a:lstStyle/>
                     <a:p>
                       <a:r>
-                        <a:rPr lang="en-US" sz="1600"/>
+                        <a:rPr lang="en-US" sz="1100" dirty="0" err="1"/>
                         <a:t>JupyterEnterpriseGateway</a:t>
                       </a:r>
+                      <a:endParaRPr lang="en-US" sz="1100" dirty="0"/>
                     </a:p>
                   </a:txBody>
                   <a:tcPr marL="26131" marR="26131" marT="13066" marB="13066" anchor="ctr"/>
@@ -34400,7 +34315,7 @@
                     <a:lstStyle/>
                     <a:p>
                       <a:r>
-                        <a:rPr lang="en-US" sz="1600"/>
+                        <a:rPr lang="en-US" sz="1100"/>
                         <a:t>Enables remote access to Jupyter kernels on distributed clusters.</a:t>
                       </a:r>
                     </a:p>
@@ -34413,13 +34328,13 @@
                   </a:ext>
                 </a:extLst>
               </a:tr>
-              <a:tr h="182920">
+              <a:tr h="228600">
                 <a:tc>
                   <a:txBody>
                     <a:bodyPr/>
                     <a:lstStyle/>
                     <a:p>
-                      <a:endParaRPr lang="en-US" sz="1600"/>
+                      <a:endParaRPr lang="en-US" sz="1100" dirty="0"/>
                     </a:p>
                   </a:txBody>
                   <a:tcPr marL="26131" marR="26131" marT="13066" marB="13066" anchor="ctr"/>
@@ -34430,7 +34345,7 @@
                     <a:lstStyle/>
                     <a:p>
                       <a:r>
-                        <a:rPr lang="en-US" sz="1600"/>
+                        <a:rPr lang="en-US" sz="1100"/>
                         <a:t>JupyterHub</a:t>
                       </a:r>
                     </a:p>
@@ -34443,15 +34358,15 @@
                     <a:lstStyle/>
                     <a:p>
                       <a:r>
-                        <a:rPr lang="en-US" sz="1600" dirty="0"/>
+                        <a:rPr lang="en-US" sz="1100" dirty="0"/>
                         <a:t>Multi-user </a:t>
                       </a:r>
                       <a:r>
-                        <a:rPr lang="en-US" sz="1600" dirty="0" err="1"/>
+                        <a:rPr lang="en-US" sz="1100" dirty="0" err="1"/>
                         <a:t>Jupyter</a:t>
                       </a:r>
                       <a:r>
-                        <a:rPr lang="en-US" sz="1600" dirty="0"/>
+                        <a:rPr lang="en-US" sz="1100" dirty="0"/>
                         <a:t> notebook server.</a:t>
                       </a:r>
                     </a:p>
@@ -34461,6 +34376,513 @@
                 <a:extLst>
                   <a:ext uri="{0D108BD9-81ED-4DB2-BD59-A6C34878D82A}">
                     <a16:rowId xmlns:a16="http://schemas.microsoft.com/office/drawing/2014/main" val="3913488872"/>
+                  </a:ext>
+                </a:extLst>
+              </a:tr>
+              <a:tr h="228600">
+                <a:tc>
+                  <a:txBody>
+                    <a:bodyPr/>
+                    <a:lstStyle/>
+                    <a:p>
+                      <a:r>
+                        <a:rPr lang="en-US" sz="1100" b="1" dirty="0"/>
+                        <a:t>SQL/Data Warehousing</a:t>
+                      </a:r>
+                      <a:endParaRPr lang="en-US" sz="1100" dirty="0"/>
+                    </a:p>
+                  </a:txBody>
+                  <a:tcPr marL="26131" marR="26131" marT="13066" marB="13066" anchor="ctr"/>
+                </a:tc>
+                <a:tc>
+                  <a:txBody>
+                    <a:bodyPr/>
+                    <a:lstStyle/>
+                    <a:p>
+                      <a:r>
+                        <a:rPr lang="en-US" sz="1100"/>
+                        <a:t>Hive</a:t>
+                      </a:r>
+                    </a:p>
+                  </a:txBody>
+                  <a:tcPr marL="26131" marR="26131" marT="13066" marB="13066" anchor="ctr"/>
+                </a:tc>
+                <a:tc>
+                  <a:txBody>
+                    <a:bodyPr/>
+                    <a:lstStyle/>
+                    <a:p>
+                      <a:r>
+                        <a:rPr lang="en-US" sz="1100" dirty="0"/>
+                        <a:t>SQL-like interface for querying large datasets on Hadoop.</a:t>
+                      </a:r>
+                    </a:p>
+                  </a:txBody>
+                  <a:tcPr marL="26131" marR="26131" marT="13066" marB="13066" anchor="ctr"/>
+                </a:tc>
+                <a:extLst>
+                  <a:ext uri="{0D108BD9-81ED-4DB2-BD59-A6C34878D82A}">
+                    <a16:rowId xmlns:a16="http://schemas.microsoft.com/office/drawing/2014/main" val="880281251"/>
+                  </a:ext>
+                </a:extLst>
+              </a:tr>
+              <a:tr h="228600">
+                <a:tc>
+                  <a:txBody>
+                    <a:bodyPr/>
+                    <a:lstStyle/>
+                    <a:p>
+                      <a:endParaRPr lang="en-US" sz="1100" dirty="0"/>
+                    </a:p>
+                  </a:txBody>
+                  <a:tcPr marL="26131" marR="26131" marT="13066" marB="13066" anchor="ctr"/>
+                </a:tc>
+                <a:tc>
+                  <a:txBody>
+                    <a:bodyPr/>
+                    <a:lstStyle/>
+                    <a:p>
+                      <a:r>
+                        <a:rPr lang="en-US" sz="1100" dirty="0" err="1"/>
+                        <a:t>HCatalog</a:t>
+                      </a:r>
+                      <a:endParaRPr lang="en-US" sz="1100" dirty="0"/>
+                    </a:p>
+                  </a:txBody>
+                  <a:tcPr marL="26131" marR="26131" marT="13066" marB="13066" anchor="ctr"/>
+                </a:tc>
+                <a:tc>
+                  <a:txBody>
+                    <a:bodyPr/>
+                    <a:lstStyle/>
+                    <a:p>
+                      <a:r>
+                        <a:rPr lang="en-US" sz="1100"/>
+                        <a:t>Table and metadata management layer for Hive.</a:t>
+                      </a:r>
+                    </a:p>
+                  </a:txBody>
+                  <a:tcPr marL="26131" marR="26131" marT="13066" marB="13066" anchor="ctr"/>
+                </a:tc>
+                <a:extLst>
+                  <a:ext uri="{0D108BD9-81ED-4DB2-BD59-A6C34878D82A}">
+                    <a16:rowId xmlns:a16="http://schemas.microsoft.com/office/drawing/2014/main" val="829274047"/>
+                  </a:ext>
+                </a:extLst>
+              </a:tr>
+              <a:tr h="228600">
+                <a:tc>
+                  <a:txBody>
+                    <a:bodyPr/>
+                    <a:lstStyle/>
+                    <a:p>
+                      <a:r>
+                        <a:rPr lang="en-US" sz="1100" b="1" dirty="0"/>
+                        <a:t>Workflow Management</a:t>
+                      </a:r>
+                      <a:endParaRPr lang="en-US" sz="1100" dirty="0"/>
+                    </a:p>
+                  </a:txBody>
+                  <a:tcPr marL="26131" marR="26131" marT="13066" marB="13066" anchor="ctr"/>
+                </a:tc>
+                <a:tc>
+                  <a:txBody>
+                    <a:bodyPr/>
+                    <a:lstStyle/>
+                    <a:p>
+                      <a:r>
+                        <a:rPr lang="en-US" sz="1100"/>
+                        <a:t>Oozie</a:t>
+                      </a:r>
+                    </a:p>
+                  </a:txBody>
+                  <a:tcPr marL="26131" marR="26131" marT="13066" marB="13066" anchor="ctr"/>
+                </a:tc>
+                <a:tc>
+                  <a:txBody>
+                    <a:bodyPr/>
+                    <a:lstStyle/>
+                    <a:p>
+                      <a:r>
+                        <a:rPr lang="en-US" sz="1100"/>
+                        <a:t>Workflow scheduler system to manage Hadoop jobs.</a:t>
+                      </a:r>
+                    </a:p>
+                  </a:txBody>
+                  <a:tcPr marL="26131" marR="26131" marT="13066" marB="13066" anchor="ctr"/>
+                </a:tc>
+                <a:extLst>
+                  <a:ext uri="{0D108BD9-81ED-4DB2-BD59-A6C34878D82A}">
+                    <a16:rowId xmlns:a16="http://schemas.microsoft.com/office/drawing/2014/main" val="2644550022"/>
+                  </a:ext>
+                </a:extLst>
+              </a:tr>
+              <a:tr h="228600">
+                <a:tc>
+                  <a:txBody>
+                    <a:bodyPr/>
+                    <a:lstStyle/>
+                    <a:p>
+                      <a:endParaRPr lang="en-US" sz="1100" dirty="0"/>
+                    </a:p>
+                  </a:txBody>
+                  <a:tcPr marL="26131" marR="26131" marT="13066" marB="13066" anchor="ctr"/>
+                </a:tc>
+                <a:tc>
+                  <a:txBody>
+                    <a:bodyPr/>
+                    <a:lstStyle/>
+                    <a:p>
+                      <a:r>
+                        <a:rPr lang="en-US" sz="1100"/>
+                        <a:t>Tez</a:t>
+                      </a:r>
+                    </a:p>
+                  </a:txBody>
+                  <a:tcPr marL="26131" marR="26131" marT="13066" marB="13066" anchor="ctr"/>
+                </a:tc>
+                <a:tc>
+                  <a:txBody>
+                    <a:bodyPr/>
+                    <a:lstStyle/>
+                    <a:p>
+                      <a:r>
+                        <a:rPr lang="en-US" sz="1100" dirty="0"/>
+                        <a:t>Framework for building data processing tasks on YARN.</a:t>
+                      </a:r>
+                    </a:p>
+                  </a:txBody>
+                  <a:tcPr marL="26131" marR="26131" marT="13066" marB="13066" anchor="ctr"/>
+                </a:tc>
+                <a:extLst>
+                  <a:ext uri="{0D108BD9-81ED-4DB2-BD59-A6C34878D82A}">
+                    <a16:rowId xmlns:a16="http://schemas.microsoft.com/office/drawing/2014/main" val="1587149059"/>
+                  </a:ext>
+                </a:extLst>
+              </a:tr>
+              <a:tr h="228600">
+                <a:tc>
+                  <a:txBody>
+                    <a:bodyPr/>
+                    <a:lstStyle/>
+                    <a:p>
+                      <a:r>
+                        <a:rPr lang="en-US" sz="1100" b="1" dirty="0"/>
+                        <a:t>Streaming &amp; Interfaces</a:t>
+                      </a:r>
+                      <a:endParaRPr lang="en-US" sz="1100" dirty="0"/>
+                    </a:p>
+                  </a:txBody>
+                  <a:tcPr marL="26131" marR="26131" marT="13066" marB="13066" anchor="ctr"/>
+                </a:tc>
+                <a:tc>
+                  <a:txBody>
+                    <a:bodyPr/>
+                    <a:lstStyle/>
+                    <a:p>
+                      <a:r>
+                        <a:rPr lang="en-US" sz="1100" dirty="0"/>
+                        <a:t>Livy</a:t>
+                      </a:r>
+                    </a:p>
+                  </a:txBody>
+                  <a:tcPr marL="26131" marR="26131" marT="13066" marB="13066" anchor="ctr"/>
+                </a:tc>
+                <a:tc>
+                  <a:txBody>
+                    <a:bodyPr/>
+                    <a:lstStyle/>
+                    <a:p>
+                      <a:r>
+                        <a:rPr lang="en-US" sz="1100" dirty="0"/>
+                        <a:t>REST API for interacting with Spark.</a:t>
+                      </a:r>
+                    </a:p>
+                  </a:txBody>
+                  <a:tcPr marL="26131" marR="26131" marT="13066" marB="13066" anchor="ctr"/>
+                </a:tc>
+                <a:extLst>
+                  <a:ext uri="{0D108BD9-81ED-4DB2-BD59-A6C34878D82A}">
+                    <a16:rowId xmlns:a16="http://schemas.microsoft.com/office/drawing/2014/main" val="18097629"/>
+                  </a:ext>
+                </a:extLst>
+              </a:tr>
+              <a:tr h="228600">
+                <a:tc>
+                  <a:txBody>
+                    <a:bodyPr/>
+                    <a:lstStyle/>
+                    <a:p>
+                      <a:endParaRPr lang="en-US" sz="1100" dirty="0"/>
+                    </a:p>
+                  </a:txBody>
+                  <a:tcPr marL="26131" marR="26131" marT="13066" marB="13066" anchor="ctr"/>
+                </a:tc>
+                <a:tc>
+                  <a:txBody>
+                    <a:bodyPr/>
+                    <a:lstStyle/>
+                    <a:p>
+                      <a:r>
+                        <a:rPr lang="en-US" sz="1100"/>
+                        <a:t>Zeppelin</a:t>
+                      </a:r>
+                    </a:p>
+                  </a:txBody>
+                  <a:tcPr marL="26131" marR="26131" marT="13066" marB="13066" anchor="ctr"/>
+                </a:tc>
+                <a:tc>
+                  <a:txBody>
+                    <a:bodyPr/>
+                    <a:lstStyle/>
+                    <a:p>
+                      <a:r>
+                        <a:rPr lang="en-US" sz="1100"/>
+                        <a:t>Web-based notebook for data exploration and visualization.</a:t>
+                      </a:r>
+                    </a:p>
+                  </a:txBody>
+                  <a:tcPr marL="26131" marR="26131" marT="13066" marB="13066" anchor="ctr"/>
+                </a:tc>
+                <a:extLst>
+                  <a:ext uri="{0D108BD9-81ED-4DB2-BD59-A6C34878D82A}">
+                    <a16:rowId xmlns:a16="http://schemas.microsoft.com/office/drawing/2014/main" val="3000635403"/>
+                  </a:ext>
+                </a:extLst>
+              </a:tr>
+              <a:tr h="228600">
+                <a:tc>
+                  <a:txBody>
+                    <a:bodyPr/>
+                    <a:lstStyle/>
+                    <a:p>
+                      <a:r>
+                        <a:rPr lang="en-US" sz="1100" b="1" dirty="0"/>
+                        <a:t>Scripting</a:t>
+                      </a:r>
+                      <a:endParaRPr lang="en-US" sz="1100" dirty="0"/>
+                    </a:p>
+                  </a:txBody>
+                  <a:tcPr marL="26131" marR="26131" marT="13066" marB="13066" anchor="ctr"/>
+                </a:tc>
+                <a:tc>
+                  <a:txBody>
+                    <a:bodyPr/>
+                    <a:lstStyle/>
+                    <a:p>
+                      <a:r>
+                        <a:rPr lang="en-US" sz="1100"/>
+                        <a:t>Pig</a:t>
+                      </a:r>
+                    </a:p>
+                  </a:txBody>
+                  <a:tcPr marL="26131" marR="26131" marT="13066" marB="13066" anchor="ctr"/>
+                </a:tc>
+                <a:tc>
+                  <a:txBody>
+                    <a:bodyPr/>
+                    <a:lstStyle/>
+                    <a:p>
+                      <a:r>
+                        <a:rPr lang="en-US" sz="1100"/>
+                        <a:t>High-level scripting platform for Hadoop.</a:t>
+                      </a:r>
+                    </a:p>
+                  </a:txBody>
+                  <a:tcPr marL="26131" marR="26131" marT="13066" marB="13066" anchor="ctr"/>
+                </a:tc>
+                <a:extLst>
+                  <a:ext uri="{0D108BD9-81ED-4DB2-BD59-A6C34878D82A}">
+                    <a16:rowId xmlns:a16="http://schemas.microsoft.com/office/drawing/2014/main" val="2538208629"/>
+                  </a:ext>
+                </a:extLst>
+              </a:tr>
+              <a:tr h="228600">
+                <a:tc>
+                  <a:txBody>
+                    <a:bodyPr/>
+                    <a:lstStyle/>
+                    <a:p>
+                      <a:r>
+                        <a:rPr lang="en-US" sz="1100" b="1" dirty="0"/>
+                        <a:t>Monitoring</a:t>
+                      </a:r>
+                      <a:endParaRPr lang="en-US" sz="1100" dirty="0"/>
+                    </a:p>
+                  </a:txBody>
+                  <a:tcPr marL="26131" marR="26131" marT="13066" marB="13066" anchor="ctr"/>
+                </a:tc>
+                <a:tc>
+                  <a:txBody>
+                    <a:bodyPr/>
+                    <a:lstStyle/>
+                    <a:p>
+                      <a:r>
+                        <a:rPr lang="en-US" sz="1100"/>
+                        <a:t>AmazonCloudWatchAgent</a:t>
+                      </a:r>
+                    </a:p>
+                  </a:txBody>
+                  <a:tcPr marL="26131" marR="26131" marT="13066" marB="13066" anchor="ctr"/>
+                </a:tc>
+                <a:tc>
+                  <a:txBody>
+                    <a:bodyPr/>
+                    <a:lstStyle/>
+                    <a:p>
+                      <a:r>
+                        <a:rPr lang="en-US" sz="1100" dirty="0"/>
+                        <a:t>Sends system metrics and logs to Amazon CloudWatch.</a:t>
+                      </a:r>
+                    </a:p>
+                  </a:txBody>
+                  <a:tcPr marL="26131" marR="26131" marT="13066" marB="13066" anchor="ctr"/>
+                </a:tc>
+                <a:extLst>
+                  <a:ext uri="{0D108BD9-81ED-4DB2-BD59-A6C34878D82A}">
+                    <a16:rowId xmlns:a16="http://schemas.microsoft.com/office/drawing/2014/main" val="347153546"/>
+                  </a:ext>
+                </a:extLst>
+              </a:tr>
+              <a:tr h="228600">
+                <a:tc>
+                  <a:txBody>
+                    <a:bodyPr/>
+                    <a:lstStyle/>
+                    <a:p>
+                      <a:r>
+                        <a:rPr lang="en-US" sz="1100" b="1" dirty="0"/>
+                        <a:t>Machine Learning</a:t>
+                      </a:r>
+                      <a:endParaRPr lang="en-US" sz="1100" dirty="0"/>
+                    </a:p>
+                  </a:txBody>
+                  <a:tcPr marL="26131" marR="26131" marT="13066" marB="13066" anchor="ctr"/>
+                </a:tc>
+                <a:tc>
+                  <a:txBody>
+                    <a:bodyPr/>
+                    <a:lstStyle/>
+                    <a:p>
+                      <a:r>
+                        <a:rPr lang="en-US" sz="1100"/>
+                        <a:t>TensorFlow</a:t>
+                      </a:r>
+                    </a:p>
+                  </a:txBody>
+                  <a:tcPr marL="26131" marR="26131" marT="13066" marB="13066" anchor="ctr"/>
+                </a:tc>
+                <a:tc>
+                  <a:txBody>
+                    <a:bodyPr/>
+                    <a:lstStyle/>
+                    <a:p>
+                      <a:r>
+                        <a:rPr lang="en-US" sz="1100" dirty="0"/>
+                        <a:t>Open-source machine learning framework by Google.</a:t>
+                      </a:r>
+                    </a:p>
+                  </a:txBody>
+                  <a:tcPr marL="26131" marR="26131" marT="13066" marB="13066" anchor="ctr"/>
+                </a:tc>
+                <a:extLst>
+                  <a:ext uri="{0D108BD9-81ED-4DB2-BD59-A6C34878D82A}">
+                    <a16:rowId xmlns:a16="http://schemas.microsoft.com/office/drawing/2014/main" val="904414348"/>
+                  </a:ext>
+                </a:extLst>
+              </a:tr>
+              <a:tr h="228600">
+                <a:tc>
+                  <a:txBody>
+                    <a:bodyPr/>
+                    <a:lstStyle/>
+                    <a:p>
+                      <a:r>
+                        <a:rPr lang="en-US" sz="1100" b="1" dirty="0"/>
+                        <a:t>Data Management</a:t>
+                      </a:r>
+                      <a:endParaRPr lang="en-US" sz="1100" dirty="0"/>
+                    </a:p>
+                  </a:txBody>
+                  <a:tcPr marL="26131" marR="26131" marT="13066" marB="13066" anchor="ctr"/>
+                </a:tc>
+                <a:tc>
+                  <a:txBody>
+                    <a:bodyPr/>
+                    <a:lstStyle/>
+                    <a:p>
+                      <a:r>
+                        <a:rPr lang="en-US" sz="1100"/>
+                        <a:t>Hue</a:t>
+                      </a:r>
+                    </a:p>
+                  </a:txBody>
+                  <a:tcPr marL="26131" marR="26131" marT="13066" marB="13066" anchor="ctr"/>
+                </a:tc>
+                <a:tc>
+                  <a:txBody>
+                    <a:bodyPr/>
+                    <a:lstStyle/>
+                    <a:p>
+                      <a:r>
+                        <a:rPr lang="en-US" sz="1100"/>
+                        <a:t>Web UI for Hadoop ecosystem (Hive, Pig, HDFS, etc.).</a:t>
+                      </a:r>
+                    </a:p>
+                  </a:txBody>
+                  <a:tcPr marL="26131" marR="26131" marT="13066" marB="13066" anchor="ctr"/>
+                </a:tc>
+                <a:extLst>
+                  <a:ext uri="{0D108BD9-81ED-4DB2-BD59-A6C34878D82A}">
+                    <a16:rowId xmlns:a16="http://schemas.microsoft.com/office/drawing/2014/main" val="3641851182"/>
+                  </a:ext>
+                </a:extLst>
+              </a:tr>
+              <a:tr h="228600">
+                <a:tc>
+                  <a:txBody>
+                    <a:bodyPr/>
+                    <a:lstStyle/>
+                    <a:p>
+                      <a:r>
+                        <a:rPr lang="en-US" sz="1100" b="1" dirty="0"/>
+                        <a:t>Coordination Services</a:t>
+                      </a:r>
+                      <a:endParaRPr lang="en-US" sz="1100" dirty="0"/>
+                    </a:p>
+                  </a:txBody>
+                  <a:tcPr marL="26131" marR="26131" marT="13066" marB="13066" anchor="ctr"/>
+                </a:tc>
+                <a:tc>
+                  <a:txBody>
+                    <a:bodyPr/>
+                    <a:lstStyle/>
+                    <a:p>
+                      <a:r>
+                        <a:rPr lang="en-US" sz="1100" dirty="0" err="1"/>
+                        <a:t>ZooKeeper</a:t>
+                      </a:r>
+                      <a:endParaRPr lang="en-US" sz="1100" dirty="0"/>
+                    </a:p>
+                  </a:txBody>
+                  <a:tcPr marL="26131" marR="26131" marT="13066" marB="13066" anchor="ctr"/>
+                </a:tc>
+                <a:tc>
+                  <a:txBody>
+                    <a:bodyPr/>
+                    <a:lstStyle/>
+                    <a:p>
+                      <a:r>
+                        <a:rPr lang="en-US" sz="1100" dirty="0"/>
+                        <a:t>Coordination service for distributed applications.</a:t>
+                      </a:r>
+                    </a:p>
+                  </a:txBody>
+                  <a:tcPr marL="26131" marR="26131" marT="13066" marB="13066" anchor="ctr"/>
+                </a:tc>
+                <a:extLst>
+                  <a:ext uri="{0D108BD9-81ED-4DB2-BD59-A6C34878D82A}">
+                    <a16:rowId xmlns:a16="http://schemas.microsoft.com/office/drawing/2014/main" val="627493989"/>
                   </a:ext>
                 </a:extLst>
               </a:tr>
@@ -34482,703 +34904,6 @@
 </file>
 
 <file path=ppt/slides/slide37.xml><?xml version="1.0" encoding="utf-8"?>
-<p:sld xmlns:a="http://schemas.openxmlformats.org/drawingml/2006/main" xmlns:r="http://schemas.openxmlformats.org/officeDocument/2006/relationships" xmlns:p="http://schemas.openxmlformats.org/presentationml/2006/main">
-  <p:cSld>
-    <p:spTree>
-      <p:nvGrpSpPr>
-        <p:cNvPr id="1" name="">
-          <a:extLst>
-            <a:ext uri="{FF2B5EF4-FFF2-40B4-BE49-F238E27FC236}">
-              <a16:creationId xmlns:a16="http://schemas.microsoft.com/office/drawing/2014/main" id="{9FC21C68-141B-377D-D7AA-091CE5A75668}"/>
-            </a:ext>
-          </a:extLst>
-        </p:cNvPr>
-        <p:cNvGrpSpPr/>
-        <p:nvPr/>
-      </p:nvGrpSpPr>
-      <p:grpSpPr>
-        <a:xfrm>
-          <a:off x="0" y="0"/>
-          <a:ext cx="0" cy="0"/>
-          <a:chOff x="0" y="0"/>
-          <a:chExt cx="0" cy="0"/>
-        </a:xfrm>
-      </p:grpSpPr>
-      <p:sp>
-        <p:nvSpPr>
-          <p:cNvPr id="4" name="Title 3">
-            <a:extLst>
-              <a:ext uri="{FF2B5EF4-FFF2-40B4-BE49-F238E27FC236}">
-                <a16:creationId xmlns:a16="http://schemas.microsoft.com/office/drawing/2014/main" id="{9BCE9FC9-48AF-A06D-333F-CAD778BA3C42}"/>
-              </a:ext>
-            </a:extLst>
-          </p:cNvPr>
-          <p:cNvSpPr>
-            <a:spLocks noGrp="1"/>
-          </p:cNvSpPr>
-          <p:nvPr>
-            <p:ph type="title"/>
-          </p:nvPr>
-        </p:nvSpPr>
-        <p:spPr/>
-        <p:txBody>
-          <a:bodyPr/>
-          <a:lstStyle/>
-          <a:p>
-            <a:r>
-              <a:rPr lang="en-US" dirty="0"/>
-              <a:t>Big Data Components in AWS EMR</a:t>
-            </a:r>
-          </a:p>
-        </p:txBody>
-      </p:sp>
-      <p:graphicFrame>
-        <p:nvGraphicFramePr>
-          <p:cNvPr id="6" name="Content Placeholder 5">
-            <a:extLst>
-              <a:ext uri="{FF2B5EF4-FFF2-40B4-BE49-F238E27FC236}">
-                <a16:creationId xmlns:a16="http://schemas.microsoft.com/office/drawing/2014/main" id="{B0C6CA0B-7FA4-E3D3-B623-72B2993B6A8A}"/>
-              </a:ext>
-            </a:extLst>
-          </p:cNvPr>
-          <p:cNvGraphicFramePr>
-            <a:graphicFrameLocks noGrp="1"/>
-          </p:cNvGraphicFramePr>
-          <p:nvPr>
-            <p:ph idx="1"/>
-            <p:extLst>
-              <p:ext uri="{D42A27DB-BD31-4B8C-83A1-F6EECF244321}">
-                <p14:modId xmlns:p14="http://schemas.microsoft.com/office/powerpoint/2010/main" val="2570265432"/>
-              </p:ext>
-            </p:extLst>
-          </p:nvPr>
-        </p:nvGraphicFramePr>
-        <p:xfrm>
-          <a:off x="284085" y="1706564"/>
-          <a:ext cx="11069715" cy="3239664"/>
-        </p:xfrm>
-        <a:graphic>
-          <a:graphicData uri="http://schemas.openxmlformats.org/drawingml/2006/table">
-            <a:tbl>
-              <a:tblPr>
-                <a:tableStyleId>{616DA210-FB5B-4158-B5E0-FEB733F419BA}</a:tableStyleId>
-              </a:tblPr>
-              <a:tblGrid>
-                <a:gridCol w="3033508">
-                  <a:extLst>
-                    <a:ext uri="{9D8B030D-6E8A-4147-A177-3AD203B41FA5}">
-                      <a16:colId xmlns:a16="http://schemas.microsoft.com/office/drawing/2014/main" val="4253224905"/>
-                    </a:ext>
-                  </a:extLst>
-                </a:gridCol>
-                <a:gridCol w="3033508">
-                  <a:extLst>
-                    <a:ext uri="{9D8B030D-6E8A-4147-A177-3AD203B41FA5}">
-                      <a16:colId xmlns:a16="http://schemas.microsoft.com/office/drawing/2014/main" val="2322419839"/>
-                    </a:ext>
-                  </a:extLst>
-                </a:gridCol>
-                <a:gridCol w="5002699">
-                  <a:extLst>
-                    <a:ext uri="{9D8B030D-6E8A-4147-A177-3AD203B41FA5}">
-                      <a16:colId xmlns:a16="http://schemas.microsoft.com/office/drawing/2014/main" val="3164467908"/>
-                    </a:ext>
-                  </a:extLst>
-                </a:gridCol>
-              </a:tblGrid>
-              <a:tr h="104526">
-                <a:tc>
-                  <a:txBody>
-                    <a:bodyPr/>
-                    <a:lstStyle/>
-                    <a:p>
-                      <a:pPr algn="ctr"/>
-                      <a:r>
-                        <a:rPr lang="en-US" sz="1600" b="1"/>
-                        <a:t>Category</a:t>
-                      </a:r>
-                      <a:endParaRPr lang="en-US" sz="1600"/>
-                    </a:p>
-                  </a:txBody>
-                  <a:tcPr marL="26131" marR="26131" marT="13066" marB="13066" anchor="ctr">
-                    <a:solidFill>
-                      <a:schemeClr val="bg1">
-                        <a:lumMod val="85000"/>
-                      </a:schemeClr>
-                    </a:solidFill>
-                  </a:tcPr>
-                </a:tc>
-                <a:tc>
-                  <a:txBody>
-                    <a:bodyPr/>
-                    <a:lstStyle/>
-                    <a:p>
-                      <a:pPr algn="ctr"/>
-                      <a:r>
-                        <a:rPr lang="en-US" sz="1600" b="1"/>
-                        <a:t>Application</a:t>
-                      </a:r>
-                      <a:endParaRPr lang="en-US" sz="1600"/>
-                    </a:p>
-                  </a:txBody>
-                  <a:tcPr marL="26131" marR="26131" marT="13066" marB="13066" anchor="ctr">
-                    <a:solidFill>
-                      <a:schemeClr val="bg1">
-                        <a:lumMod val="85000"/>
-                      </a:schemeClr>
-                    </a:solidFill>
-                  </a:tcPr>
-                </a:tc>
-                <a:tc>
-                  <a:txBody>
-                    <a:bodyPr/>
-                    <a:lstStyle/>
-                    <a:p>
-                      <a:pPr algn="ctr"/>
-                      <a:r>
-                        <a:rPr lang="en-US" sz="1600" b="1" dirty="0"/>
-                        <a:t>Description</a:t>
-                      </a:r>
-                      <a:endParaRPr lang="en-US" sz="1600" dirty="0"/>
-                    </a:p>
-                  </a:txBody>
-                  <a:tcPr marL="26131" marR="26131" marT="13066" marB="13066" anchor="ctr">
-                    <a:solidFill>
-                      <a:schemeClr val="bg1">
-                        <a:lumMod val="85000"/>
-                      </a:schemeClr>
-                    </a:solidFill>
-                  </a:tcPr>
-                </a:tc>
-                <a:extLst>
-                  <a:ext uri="{0D108BD9-81ED-4DB2-BD59-A6C34878D82A}">
-                    <a16:rowId xmlns:a16="http://schemas.microsoft.com/office/drawing/2014/main" val="1462678468"/>
-                  </a:ext>
-                </a:extLst>
-              </a:tr>
-              <a:tr h="261314">
-                <a:tc>
-                  <a:txBody>
-                    <a:bodyPr/>
-                    <a:lstStyle/>
-                    <a:p>
-                      <a:r>
-                        <a:rPr lang="en-US" sz="1600" b="1"/>
-                        <a:t>SQL/Data Warehousing</a:t>
-                      </a:r>
-                      <a:endParaRPr lang="en-US" sz="1600"/>
-                    </a:p>
-                  </a:txBody>
-                  <a:tcPr marL="26131" marR="26131" marT="13066" marB="13066" anchor="ctr"/>
-                </a:tc>
-                <a:tc>
-                  <a:txBody>
-                    <a:bodyPr/>
-                    <a:lstStyle/>
-                    <a:p>
-                      <a:r>
-                        <a:rPr lang="en-US" sz="1600"/>
-                        <a:t>Hive</a:t>
-                      </a:r>
-                    </a:p>
-                  </a:txBody>
-                  <a:tcPr marL="26131" marR="26131" marT="13066" marB="13066" anchor="ctr"/>
-                </a:tc>
-                <a:tc>
-                  <a:txBody>
-                    <a:bodyPr/>
-                    <a:lstStyle/>
-                    <a:p>
-                      <a:r>
-                        <a:rPr lang="en-US" sz="1600" dirty="0"/>
-                        <a:t>SQL-like interface for querying large datasets on Hadoop.</a:t>
-                      </a:r>
-                    </a:p>
-                  </a:txBody>
-                  <a:tcPr marL="26131" marR="26131" marT="13066" marB="13066" anchor="ctr"/>
-                </a:tc>
-                <a:extLst>
-                  <a:ext uri="{0D108BD9-81ED-4DB2-BD59-A6C34878D82A}">
-                    <a16:rowId xmlns:a16="http://schemas.microsoft.com/office/drawing/2014/main" val="120359175"/>
-                  </a:ext>
-                </a:extLst>
-              </a:tr>
-              <a:tr h="261314">
-                <a:tc>
-                  <a:txBody>
-                    <a:bodyPr/>
-                    <a:lstStyle/>
-                    <a:p>
-                      <a:endParaRPr lang="en-US" sz="1600" dirty="0"/>
-                    </a:p>
-                  </a:txBody>
-                  <a:tcPr marL="26131" marR="26131" marT="13066" marB="13066" anchor="ctr"/>
-                </a:tc>
-                <a:tc>
-                  <a:txBody>
-                    <a:bodyPr/>
-                    <a:lstStyle/>
-                    <a:p>
-                      <a:r>
-                        <a:rPr lang="en-US" sz="1600"/>
-                        <a:t>HCatalog</a:t>
-                      </a:r>
-                    </a:p>
-                  </a:txBody>
-                  <a:tcPr marL="26131" marR="26131" marT="13066" marB="13066" anchor="ctr"/>
-                </a:tc>
-                <a:tc>
-                  <a:txBody>
-                    <a:bodyPr/>
-                    <a:lstStyle/>
-                    <a:p>
-                      <a:r>
-                        <a:rPr lang="en-US" sz="1600"/>
-                        <a:t>Table and metadata management layer for Hive.</a:t>
-                      </a:r>
-                    </a:p>
-                  </a:txBody>
-                  <a:tcPr marL="26131" marR="26131" marT="13066" marB="13066" anchor="ctr"/>
-                </a:tc>
-                <a:extLst>
-                  <a:ext uri="{0D108BD9-81ED-4DB2-BD59-A6C34878D82A}">
-                    <a16:rowId xmlns:a16="http://schemas.microsoft.com/office/drawing/2014/main" val="1520290482"/>
-                  </a:ext>
-                </a:extLst>
-              </a:tr>
-              <a:tr h="261314">
-                <a:tc>
-                  <a:txBody>
-                    <a:bodyPr/>
-                    <a:lstStyle/>
-                    <a:p>
-                      <a:r>
-                        <a:rPr lang="en-US" sz="1600" b="1"/>
-                        <a:t>Workflow Management</a:t>
-                      </a:r>
-                      <a:endParaRPr lang="en-US" sz="1600"/>
-                    </a:p>
-                  </a:txBody>
-                  <a:tcPr marL="26131" marR="26131" marT="13066" marB="13066" anchor="ctr"/>
-                </a:tc>
-                <a:tc>
-                  <a:txBody>
-                    <a:bodyPr/>
-                    <a:lstStyle/>
-                    <a:p>
-                      <a:r>
-                        <a:rPr lang="en-US" sz="1600"/>
-                        <a:t>Oozie</a:t>
-                      </a:r>
-                    </a:p>
-                  </a:txBody>
-                  <a:tcPr marL="26131" marR="26131" marT="13066" marB="13066" anchor="ctr"/>
-                </a:tc>
-                <a:tc>
-                  <a:txBody>
-                    <a:bodyPr/>
-                    <a:lstStyle/>
-                    <a:p>
-                      <a:r>
-                        <a:rPr lang="en-US" sz="1600"/>
-                        <a:t>Workflow scheduler system to manage Hadoop jobs.</a:t>
-                      </a:r>
-                    </a:p>
-                  </a:txBody>
-                  <a:tcPr marL="26131" marR="26131" marT="13066" marB="13066" anchor="ctr"/>
-                </a:tc>
-                <a:extLst>
-                  <a:ext uri="{0D108BD9-81ED-4DB2-BD59-A6C34878D82A}">
-                    <a16:rowId xmlns:a16="http://schemas.microsoft.com/office/drawing/2014/main" val="1552168862"/>
-                  </a:ext>
-                </a:extLst>
-              </a:tr>
-              <a:tr h="261314">
-                <a:tc>
-                  <a:txBody>
-                    <a:bodyPr/>
-                    <a:lstStyle/>
-                    <a:p>
-                      <a:endParaRPr lang="en-US" sz="1600"/>
-                    </a:p>
-                  </a:txBody>
-                  <a:tcPr marL="26131" marR="26131" marT="13066" marB="13066" anchor="ctr"/>
-                </a:tc>
-                <a:tc>
-                  <a:txBody>
-                    <a:bodyPr/>
-                    <a:lstStyle/>
-                    <a:p>
-                      <a:r>
-                        <a:rPr lang="en-US" sz="1600"/>
-                        <a:t>Tez</a:t>
-                      </a:r>
-                    </a:p>
-                  </a:txBody>
-                  <a:tcPr marL="26131" marR="26131" marT="13066" marB="13066" anchor="ctr"/>
-                </a:tc>
-                <a:tc>
-                  <a:txBody>
-                    <a:bodyPr/>
-                    <a:lstStyle/>
-                    <a:p>
-                      <a:r>
-                        <a:rPr lang="en-US" sz="1600" dirty="0"/>
-                        <a:t>Framework for building data processing tasks on YARN.</a:t>
-                      </a:r>
-                    </a:p>
-                  </a:txBody>
-                  <a:tcPr marL="26131" marR="26131" marT="13066" marB="13066" anchor="ctr"/>
-                </a:tc>
-                <a:extLst>
-                  <a:ext uri="{0D108BD9-81ED-4DB2-BD59-A6C34878D82A}">
-                    <a16:rowId xmlns:a16="http://schemas.microsoft.com/office/drawing/2014/main" val="241954766"/>
-                  </a:ext>
-                </a:extLst>
-              </a:tr>
-              <a:tr h="182920">
-                <a:tc>
-                  <a:txBody>
-                    <a:bodyPr/>
-                    <a:lstStyle/>
-                    <a:p>
-                      <a:r>
-                        <a:rPr lang="en-US" sz="1600" b="1"/>
-                        <a:t>Streaming &amp; Interfaces</a:t>
-                      </a:r>
-                      <a:endParaRPr lang="en-US" sz="1600"/>
-                    </a:p>
-                  </a:txBody>
-                  <a:tcPr marL="26131" marR="26131" marT="13066" marB="13066" anchor="ctr"/>
-                </a:tc>
-                <a:tc>
-                  <a:txBody>
-                    <a:bodyPr/>
-                    <a:lstStyle/>
-                    <a:p>
-                      <a:r>
-                        <a:rPr lang="en-US" sz="1600"/>
-                        <a:t>Livy</a:t>
-                      </a:r>
-                    </a:p>
-                  </a:txBody>
-                  <a:tcPr marL="26131" marR="26131" marT="13066" marB="13066" anchor="ctr"/>
-                </a:tc>
-                <a:tc>
-                  <a:txBody>
-                    <a:bodyPr/>
-                    <a:lstStyle/>
-                    <a:p>
-                      <a:r>
-                        <a:rPr lang="en-US" sz="1600"/>
-                        <a:t>REST API for interacting with Spark.</a:t>
-                      </a:r>
-                    </a:p>
-                  </a:txBody>
-                  <a:tcPr marL="26131" marR="26131" marT="13066" marB="13066" anchor="ctr"/>
-                </a:tc>
-                <a:extLst>
-                  <a:ext uri="{0D108BD9-81ED-4DB2-BD59-A6C34878D82A}">
-                    <a16:rowId xmlns:a16="http://schemas.microsoft.com/office/drawing/2014/main" val="3098240838"/>
-                  </a:ext>
-                </a:extLst>
-              </a:tr>
-              <a:tr h="261314">
-                <a:tc>
-                  <a:txBody>
-                    <a:bodyPr/>
-                    <a:lstStyle/>
-                    <a:p>
-                      <a:endParaRPr lang="en-US" sz="1600"/>
-                    </a:p>
-                  </a:txBody>
-                  <a:tcPr marL="26131" marR="26131" marT="13066" marB="13066" anchor="ctr"/>
-                </a:tc>
-                <a:tc>
-                  <a:txBody>
-                    <a:bodyPr/>
-                    <a:lstStyle/>
-                    <a:p>
-                      <a:r>
-                        <a:rPr lang="en-US" sz="1600"/>
-                        <a:t>Zeppelin</a:t>
-                      </a:r>
-                    </a:p>
-                  </a:txBody>
-                  <a:tcPr marL="26131" marR="26131" marT="13066" marB="13066" anchor="ctr"/>
-                </a:tc>
-                <a:tc>
-                  <a:txBody>
-                    <a:bodyPr/>
-                    <a:lstStyle/>
-                    <a:p>
-                      <a:r>
-                        <a:rPr lang="en-US" sz="1600"/>
-                        <a:t>Web-based notebook for data exploration and visualization.</a:t>
-                      </a:r>
-                    </a:p>
-                  </a:txBody>
-                  <a:tcPr marL="26131" marR="26131" marT="13066" marB="13066" anchor="ctr"/>
-                </a:tc>
-                <a:extLst>
-                  <a:ext uri="{0D108BD9-81ED-4DB2-BD59-A6C34878D82A}">
-                    <a16:rowId xmlns:a16="http://schemas.microsoft.com/office/drawing/2014/main" val="1942461574"/>
-                  </a:ext>
-                </a:extLst>
-              </a:tr>
-              <a:tr h="182920">
-                <a:tc>
-                  <a:txBody>
-                    <a:bodyPr/>
-                    <a:lstStyle/>
-                    <a:p>
-                      <a:r>
-                        <a:rPr lang="en-US" sz="1600" b="1"/>
-                        <a:t>Scripting</a:t>
-                      </a:r>
-                      <a:endParaRPr lang="en-US" sz="1600"/>
-                    </a:p>
-                  </a:txBody>
-                  <a:tcPr marL="26131" marR="26131" marT="13066" marB="13066" anchor="ctr"/>
-                </a:tc>
-                <a:tc>
-                  <a:txBody>
-                    <a:bodyPr/>
-                    <a:lstStyle/>
-                    <a:p>
-                      <a:r>
-                        <a:rPr lang="en-US" sz="1600"/>
-                        <a:t>Pig</a:t>
-                      </a:r>
-                    </a:p>
-                  </a:txBody>
-                  <a:tcPr marL="26131" marR="26131" marT="13066" marB="13066" anchor="ctr"/>
-                </a:tc>
-                <a:tc>
-                  <a:txBody>
-                    <a:bodyPr/>
-                    <a:lstStyle/>
-                    <a:p>
-                      <a:r>
-                        <a:rPr lang="en-US" sz="1600"/>
-                        <a:t>High-level scripting platform for Hadoop.</a:t>
-                      </a:r>
-                    </a:p>
-                  </a:txBody>
-                  <a:tcPr marL="26131" marR="26131" marT="13066" marB="13066" anchor="ctr"/>
-                </a:tc>
-                <a:extLst>
-                  <a:ext uri="{0D108BD9-81ED-4DB2-BD59-A6C34878D82A}">
-                    <a16:rowId xmlns:a16="http://schemas.microsoft.com/office/drawing/2014/main" val="997706531"/>
-                  </a:ext>
-                </a:extLst>
-              </a:tr>
-              <a:tr h="261314">
-                <a:tc>
-                  <a:txBody>
-                    <a:bodyPr/>
-                    <a:lstStyle/>
-                    <a:p>
-                      <a:r>
-                        <a:rPr lang="en-US" sz="1600" b="1"/>
-                        <a:t>Monitoring</a:t>
-                      </a:r>
-                      <a:endParaRPr lang="en-US" sz="1600"/>
-                    </a:p>
-                  </a:txBody>
-                  <a:tcPr marL="26131" marR="26131" marT="13066" marB="13066" anchor="ctr"/>
-                </a:tc>
-                <a:tc>
-                  <a:txBody>
-                    <a:bodyPr/>
-                    <a:lstStyle/>
-                    <a:p>
-                      <a:r>
-                        <a:rPr lang="en-US" sz="1600"/>
-                        <a:t>AmazonCloudWatchAgent</a:t>
-                      </a:r>
-                    </a:p>
-                  </a:txBody>
-                  <a:tcPr marL="26131" marR="26131" marT="13066" marB="13066" anchor="ctr"/>
-                </a:tc>
-                <a:tc>
-                  <a:txBody>
-                    <a:bodyPr/>
-                    <a:lstStyle/>
-                    <a:p>
-                      <a:r>
-                        <a:rPr lang="en-US" sz="1600" dirty="0"/>
-                        <a:t>Sends system metrics and logs to Amazon CloudWatch.</a:t>
-                      </a:r>
-                    </a:p>
-                  </a:txBody>
-                  <a:tcPr marL="26131" marR="26131" marT="13066" marB="13066" anchor="ctr"/>
-                </a:tc>
-                <a:extLst>
-                  <a:ext uri="{0D108BD9-81ED-4DB2-BD59-A6C34878D82A}">
-                    <a16:rowId xmlns:a16="http://schemas.microsoft.com/office/drawing/2014/main" val="2923360556"/>
-                  </a:ext>
-                </a:extLst>
-              </a:tr>
-              <a:tr h="261314">
-                <a:tc>
-                  <a:txBody>
-                    <a:bodyPr/>
-                    <a:lstStyle/>
-                    <a:p>
-                      <a:r>
-                        <a:rPr lang="en-US" sz="1600" b="1"/>
-                        <a:t>Machine Learning</a:t>
-                      </a:r>
-                      <a:endParaRPr lang="en-US" sz="1600"/>
-                    </a:p>
-                  </a:txBody>
-                  <a:tcPr marL="26131" marR="26131" marT="13066" marB="13066" anchor="ctr"/>
-                </a:tc>
-                <a:tc>
-                  <a:txBody>
-                    <a:bodyPr/>
-                    <a:lstStyle/>
-                    <a:p>
-                      <a:r>
-                        <a:rPr lang="en-US" sz="1600"/>
-                        <a:t>TensorFlow</a:t>
-                      </a:r>
-                    </a:p>
-                  </a:txBody>
-                  <a:tcPr marL="26131" marR="26131" marT="13066" marB="13066" anchor="ctr"/>
-                </a:tc>
-                <a:tc>
-                  <a:txBody>
-                    <a:bodyPr/>
-                    <a:lstStyle/>
-                    <a:p>
-                      <a:r>
-                        <a:rPr lang="en-US" sz="1600" dirty="0"/>
-                        <a:t>Open-source machine learning framework by Google.</a:t>
-                      </a:r>
-                    </a:p>
-                  </a:txBody>
-                  <a:tcPr marL="26131" marR="26131" marT="13066" marB="13066" anchor="ctr"/>
-                </a:tc>
-                <a:extLst>
-                  <a:ext uri="{0D108BD9-81ED-4DB2-BD59-A6C34878D82A}">
-                    <a16:rowId xmlns:a16="http://schemas.microsoft.com/office/drawing/2014/main" val="923226335"/>
-                  </a:ext>
-                </a:extLst>
-              </a:tr>
-              <a:tr h="261314">
-                <a:tc>
-                  <a:txBody>
-                    <a:bodyPr/>
-                    <a:lstStyle/>
-                    <a:p>
-                      <a:r>
-                        <a:rPr lang="en-US" sz="1600" b="1"/>
-                        <a:t>Data Management</a:t>
-                      </a:r>
-                      <a:endParaRPr lang="en-US" sz="1600"/>
-                    </a:p>
-                  </a:txBody>
-                  <a:tcPr marL="26131" marR="26131" marT="13066" marB="13066" anchor="ctr"/>
-                </a:tc>
-                <a:tc>
-                  <a:txBody>
-                    <a:bodyPr/>
-                    <a:lstStyle/>
-                    <a:p>
-                      <a:r>
-                        <a:rPr lang="en-US" sz="1600"/>
-                        <a:t>Hue</a:t>
-                      </a:r>
-                    </a:p>
-                  </a:txBody>
-                  <a:tcPr marL="26131" marR="26131" marT="13066" marB="13066" anchor="ctr"/>
-                </a:tc>
-                <a:tc>
-                  <a:txBody>
-                    <a:bodyPr/>
-                    <a:lstStyle/>
-                    <a:p>
-                      <a:r>
-                        <a:rPr lang="en-US" sz="1600"/>
-                        <a:t>Web UI for Hadoop ecosystem (Hive, Pig, HDFS, etc.).</a:t>
-                      </a:r>
-                    </a:p>
-                  </a:txBody>
-                  <a:tcPr marL="26131" marR="26131" marT="13066" marB="13066" anchor="ctr"/>
-                </a:tc>
-                <a:extLst>
-                  <a:ext uri="{0D108BD9-81ED-4DB2-BD59-A6C34878D82A}">
-                    <a16:rowId xmlns:a16="http://schemas.microsoft.com/office/drawing/2014/main" val="1177445489"/>
-                  </a:ext>
-                </a:extLst>
-              </a:tr>
-              <a:tr h="182920">
-                <a:tc>
-                  <a:txBody>
-                    <a:bodyPr/>
-                    <a:lstStyle/>
-                    <a:p>
-                      <a:r>
-                        <a:rPr lang="en-US" sz="1600" b="1"/>
-                        <a:t>Coordination Services</a:t>
-                      </a:r>
-                      <a:endParaRPr lang="en-US" sz="1600"/>
-                    </a:p>
-                  </a:txBody>
-                  <a:tcPr marL="26131" marR="26131" marT="13066" marB="13066" anchor="ctr"/>
-                </a:tc>
-                <a:tc>
-                  <a:txBody>
-                    <a:bodyPr/>
-                    <a:lstStyle/>
-                    <a:p>
-                      <a:r>
-                        <a:rPr lang="en-US" sz="1600"/>
-                        <a:t>ZooKeeper</a:t>
-                      </a:r>
-                    </a:p>
-                  </a:txBody>
-                  <a:tcPr marL="26131" marR="26131" marT="13066" marB="13066" anchor="ctr"/>
-                </a:tc>
-                <a:tc>
-                  <a:txBody>
-                    <a:bodyPr/>
-                    <a:lstStyle/>
-                    <a:p>
-                      <a:r>
-                        <a:rPr lang="en-US" sz="1600" dirty="0"/>
-                        <a:t>Coordination service for distributed applications.</a:t>
-                      </a:r>
-                    </a:p>
-                  </a:txBody>
-                  <a:tcPr marL="26131" marR="26131" marT="13066" marB="13066" anchor="ctr"/>
-                </a:tc>
-                <a:extLst>
-                  <a:ext uri="{0D108BD9-81ED-4DB2-BD59-A6C34878D82A}">
-                    <a16:rowId xmlns:a16="http://schemas.microsoft.com/office/drawing/2014/main" val="2326770961"/>
-                  </a:ext>
-                </a:extLst>
-              </a:tr>
-            </a:tbl>
-          </a:graphicData>
-        </a:graphic>
-      </p:graphicFrame>
-    </p:spTree>
-    <p:extLst>
-      <p:ext uri="{BB962C8B-B14F-4D97-AF65-F5344CB8AC3E}">
-        <p14:creationId xmlns:p14="http://schemas.microsoft.com/office/powerpoint/2010/main" val="2432870720"/>
-      </p:ext>
-    </p:extLst>
-  </p:cSld>
-  <p:clrMapOvr>
-    <a:masterClrMapping/>
-  </p:clrMapOvr>
-</p:sld>
-</file>
-
-<file path=ppt/slides/slide38.xml><?xml version="1.0" encoding="utf-8"?>
 <p:sld xmlns:a="http://schemas.openxmlformats.org/drawingml/2006/main" xmlns:r="http://schemas.openxmlformats.org/officeDocument/2006/relationships" xmlns:p="http://schemas.openxmlformats.org/presentationml/2006/main">
   <p:cSld>
     <p:spTree>
@@ -35487,7 +35212,7 @@
 </p:sld>
 </file>
 
-<file path=ppt/slides/slide39.xml><?xml version="1.0" encoding="utf-8"?>
+<file path=ppt/slides/slide38.xml><?xml version="1.0" encoding="utf-8"?>
 <p:sld xmlns:a="http://schemas.openxmlformats.org/drawingml/2006/main" xmlns:r="http://schemas.openxmlformats.org/officeDocument/2006/relationships" xmlns:p="http://schemas.openxmlformats.org/presentationml/2006/main">
   <p:cSld>
     <p:spTree>

</xml_diff>